<commit_message>
upload video 13.1 - Parsing
</commit_message>
<xml_diff>
--- a/topic13-parsing/unit-13a-lectures/talk-1/a-parsers.pptx
+++ b/topic13-parsing/unit-13a-lectures/talk-1/a-parsers.pptx
@@ -27,7 +27,7 @@
     <p:sldId id="317" r:id="rId15"/>
     <p:sldId id="343" r:id="rId16"/>
   </p:sldIdLst>
-  <p:sldSz cx="9144000" cy="6858000" type="screen4x3"/>
+  <p:sldSz cx="12192000" cy="6858000"/>
   <p:notesSz cx="7089775" cy="10218738"/>
   <p:defaultTextStyle>
     <a:defPPr>
@@ -157,12 +157,12 @@
   <p:extLst>
     <p:ext uri="{EFAFB233-063F-42B5-8137-9DF3F51BA10A}">
       <p15:sldGuideLst xmlns:p15="http://schemas.microsoft.com/office/powerpoint/2012/main">
-        <p15:guide id="1" orient="horz" pos="2160">
+        <p15:guide id="1" orient="horz" pos="2160" userDrawn="1">
           <p15:clr>
             <a:srgbClr val="A4A3A4"/>
           </p15:clr>
         </p15:guide>
-        <p15:guide id="2" pos="2880">
+        <p15:guide id="2" pos="3840" userDrawn="1">
           <p15:clr>
             <a:srgbClr val="A4A3A4"/>
           </p15:clr>
@@ -563,8 +563,8 @@
         </p:nvSpPr>
         <p:spPr bwMode="auto">
           <a:xfrm>
-            <a:off x="1041400" y="762000"/>
-            <a:ext cx="5080000" cy="3810000"/>
+            <a:off x="195263" y="762000"/>
+            <a:ext cx="6772275" cy="3810000"/>
           </a:xfrm>
           <a:prstGeom prst="rect">
             <a:avLst/>
@@ -580,14 +580,14 @@
           </a:ln>
           <a:extLst>
             <a:ext uri="{909E8E84-426E-40dd-AFC4-6F175D3DCCD1}">
-              <a14:hiddenFill xmlns:a14="http://schemas.microsoft.com/office/drawing/2010/main" xmlns="">
+              <a14:hiddenFill xmlns="" xmlns:a14="http://schemas.microsoft.com/office/drawing/2010/main">
                 <a:solidFill>
                   <a:srgbClr val="FFFFFF"/>
                 </a:solidFill>
               </a14:hiddenFill>
             </a:ext>
             <a:ext uri="{FAA26D3D-D897-4be2-8F04-BA451C77F1D7}">
-              <ma14:placeholderFlag xmlns:ma14="http://schemas.microsoft.com/office/mac/drawingml/2011/main" xmlns="" val="1"/>
+              <ma14:placeholderFlag xmlns="" xmlns:ma14="http://schemas.microsoft.com/office/mac/drawingml/2011/main" val="1"/>
             </a:ext>
           </a:extLst>
         </p:spPr>
@@ -938,8 +938,8 @@
         </p:blipFill>
         <p:spPr>
           <a:xfrm>
-            <a:off x="1" y="4242851"/>
-            <a:ext cx="6726063" cy="275942"/>
+            <a:off x="2" y="4242851"/>
+            <a:ext cx="8968084" cy="275942"/>
           </a:xfrm>
           <a:prstGeom prst="rect">
             <a:avLst/>
@@ -968,8 +968,8 @@
         </p:blipFill>
         <p:spPr>
           <a:xfrm>
-            <a:off x="6833787" y="4243845"/>
-            <a:ext cx="2307831" cy="276940"/>
+            <a:off x="9111717" y="4243845"/>
+            <a:ext cx="3077108" cy="276940"/>
           </a:xfrm>
           <a:prstGeom prst="rect">
             <a:avLst/>
@@ -985,7 +985,7 @@
         <p:spPr bwMode="ltGray">
           <a:xfrm>
             <a:off x="0" y="2590078"/>
-            <a:ext cx="6726064" cy="1660332"/>
+            <a:ext cx="8968085" cy="1660332"/>
           </a:xfrm>
           <a:prstGeom prst="rect">
             <a:avLst/>
@@ -1025,8 +1025,8 @@
         </p:nvSpPr>
         <p:spPr>
           <a:xfrm>
-            <a:off x="6833787" y="2590078"/>
-            <a:ext cx="2307832" cy="1660332"/>
+            <a:off x="9111716" y="2590078"/>
+            <a:ext cx="3077109" cy="1660332"/>
           </a:xfrm>
           <a:prstGeom prst="rect">
             <a:avLst/>
@@ -1067,8 +1067,8 @@
         </p:nvSpPr>
         <p:spPr>
           <a:xfrm>
-            <a:off x="510241" y="2733709"/>
-            <a:ext cx="6108101" cy="1373070"/>
+            <a:off x="680322" y="2733709"/>
+            <a:ext cx="8144135" cy="1373070"/>
           </a:xfrm>
         </p:spPr>
         <p:txBody>
@@ -1101,8 +1101,8 @@
         </p:nvSpPr>
         <p:spPr>
           <a:xfrm>
-            <a:off x="510241" y="4394040"/>
-            <a:ext cx="6108101" cy="1117687"/>
+            <a:off x="680322" y="4394041"/>
+            <a:ext cx="8144135" cy="1117687"/>
           </a:xfrm>
         </p:spPr>
         <p:txBody>
@@ -1219,8 +1219,8 @@
         </p:nvSpPr>
         <p:spPr>
           <a:xfrm>
-            <a:off x="6941510" y="2750337"/>
-            <a:ext cx="878916" cy="1356442"/>
+            <a:off x="9255347" y="2750337"/>
+            <a:ext cx="1171888" cy="1356442"/>
           </a:xfrm>
         </p:spPr>
         <p:txBody>
@@ -1294,8 +1294,8 @@
         </p:blipFill>
         <p:spPr>
           <a:xfrm>
-            <a:off x="1" y="5928628"/>
-            <a:ext cx="7828359" cy="321164"/>
+            <a:off x="2" y="5928628"/>
+            <a:ext cx="10437812" cy="321164"/>
           </a:xfrm>
           <a:prstGeom prst="rect">
             <a:avLst/>
@@ -1324,8 +1324,8 @@
         </p:blipFill>
         <p:spPr>
           <a:xfrm>
-            <a:off x="7939370" y="5929622"/>
-            <a:ext cx="1202248" cy="144270"/>
+            <a:off x="10585827" y="5929622"/>
+            <a:ext cx="1602997" cy="144270"/>
           </a:xfrm>
           <a:prstGeom prst="rect">
             <a:avLst/>
@@ -1340,8 +1340,8 @@
         </p:nvSpPr>
         <p:spPr bwMode="ltGray">
           <a:xfrm>
-            <a:off x="0" y="4567988"/>
-            <a:ext cx="7828359" cy="1368198"/>
+            <a:off x="1" y="4567988"/>
+            <a:ext cx="10437812" cy="1368198"/>
           </a:xfrm>
           <a:prstGeom prst="rect">
             <a:avLst/>
@@ -1381,8 +1381,8 @@
         </p:nvSpPr>
         <p:spPr>
           <a:xfrm>
-            <a:off x="7939371" y="4567988"/>
-            <a:ext cx="1202248" cy="1368198"/>
+            <a:off x="10585828" y="4567988"/>
+            <a:ext cx="1602997" cy="1368198"/>
           </a:xfrm>
           <a:prstGeom prst="rect">
             <a:avLst/>
@@ -1423,8 +1423,8 @@
         </p:nvSpPr>
         <p:spPr>
           <a:xfrm>
-            <a:off x="510242" y="4711617"/>
-            <a:ext cx="7210394" cy="453051"/>
+            <a:off x="680322" y="4711618"/>
+            <a:ext cx="9613859" cy="453051"/>
           </a:xfrm>
         </p:spPr>
         <p:txBody>
@@ -1457,8 +1457,8 @@
         </p:nvSpPr>
         <p:spPr>
           <a:xfrm>
-            <a:off x="510242" y="609598"/>
-            <a:ext cx="7210394" cy="3589575"/>
+            <a:off x="680322" y="609599"/>
+            <a:ext cx="9613859" cy="3589575"/>
           </a:xfrm>
           <a:noFill/>
           <a:ln>
@@ -1533,8 +1533,8 @@
         </p:nvSpPr>
         <p:spPr>
           <a:xfrm>
-            <a:off x="510239" y="5169584"/>
-            <a:ext cx="7210397" cy="622971"/>
+            <a:off x="680319" y="5169585"/>
+            <a:ext cx="9613863" cy="622971"/>
           </a:xfrm>
         </p:spPr>
         <p:txBody>
@@ -1649,8 +1649,8 @@
         </p:nvSpPr>
         <p:spPr>
           <a:xfrm>
-            <a:off x="8047092" y="4711310"/>
-            <a:ext cx="865613" cy="1090789"/>
+            <a:off x="10729457" y="4711311"/>
+            <a:ext cx="1154151" cy="1090789"/>
           </a:xfrm>
         </p:spPr>
         <p:txBody>
@@ -1724,8 +1724,8 @@
         </p:blipFill>
         <p:spPr>
           <a:xfrm>
-            <a:off x="1" y="5928628"/>
-            <a:ext cx="7828359" cy="321164"/>
+            <a:off x="2" y="5928628"/>
+            <a:ext cx="10437812" cy="321164"/>
           </a:xfrm>
           <a:prstGeom prst="rect">
             <a:avLst/>
@@ -1754,8 +1754,8 @@
         </p:blipFill>
         <p:spPr>
           <a:xfrm>
-            <a:off x="7939370" y="5929622"/>
-            <a:ext cx="1202248" cy="144270"/>
+            <a:off x="10585827" y="5929622"/>
+            <a:ext cx="1602997" cy="144270"/>
           </a:xfrm>
           <a:prstGeom prst="rect">
             <a:avLst/>
@@ -1770,8 +1770,8 @@
         </p:nvSpPr>
         <p:spPr bwMode="ltGray">
           <a:xfrm>
-            <a:off x="0" y="4567988"/>
-            <a:ext cx="7828359" cy="1368198"/>
+            <a:off x="1" y="4567988"/>
+            <a:ext cx="10437812" cy="1368198"/>
           </a:xfrm>
           <a:prstGeom prst="rect">
             <a:avLst/>
@@ -1811,8 +1811,8 @@
         </p:nvSpPr>
         <p:spPr>
           <a:xfrm>
-            <a:off x="7939371" y="4567988"/>
-            <a:ext cx="1202248" cy="1368198"/>
+            <a:off x="10585828" y="4567988"/>
+            <a:ext cx="1602997" cy="1368198"/>
           </a:xfrm>
           <a:prstGeom prst="rect">
             <a:avLst/>
@@ -1853,8 +1853,8 @@
         </p:nvSpPr>
         <p:spPr>
           <a:xfrm>
-            <a:off x="510241" y="609597"/>
-            <a:ext cx="7210394" cy="3592750"/>
+            <a:off x="680321" y="609597"/>
+            <a:ext cx="9613859" cy="3592750"/>
           </a:xfrm>
         </p:spPr>
         <p:txBody>
@@ -1885,8 +1885,8 @@
         </p:nvSpPr>
         <p:spPr>
           <a:xfrm>
-            <a:off x="510242" y="4711616"/>
-            <a:ext cx="7210394" cy="1090789"/>
+            <a:off x="680322" y="4711617"/>
+            <a:ext cx="9613859" cy="1090789"/>
           </a:xfrm>
         </p:spPr>
         <p:txBody>
@@ -2001,8 +2001,8 @@
         </p:nvSpPr>
         <p:spPr>
           <a:xfrm>
-            <a:off x="8047092" y="4711616"/>
-            <a:ext cx="865613" cy="1090789"/>
+            <a:off x="10729457" y="4711617"/>
+            <a:ext cx="1154151" cy="1090789"/>
           </a:xfrm>
         </p:spPr>
         <p:txBody>
@@ -2076,8 +2076,8 @@
         </p:blipFill>
         <p:spPr>
           <a:xfrm>
-            <a:off x="1" y="5928628"/>
-            <a:ext cx="7828359" cy="321164"/>
+            <a:off x="2" y="5928628"/>
+            <a:ext cx="10437812" cy="321164"/>
           </a:xfrm>
           <a:prstGeom prst="rect">
             <a:avLst/>
@@ -2106,8 +2106,8 @@
         </p:blipFill>
         <p:spPr>
           <a:xfrm>
-            <a:off x="7939370" y="5929622"/>
-            <a:ext cx="1202248" cy="144270"/>
+            <a:off x="10585827" y="5929622"/>
+            <a:ext cx="1602997" cy="144270"/>
           </a:xfrm>
           <a:prstGeom prst="rect">
             <a:avLst/>
@@ -2122,8 +2122,8 @@
         </p:nvSpPr>
         <p:spPr bwMode="ltGray">
           <a:xfrm>
-            <a:off x="0" y="4567988"/>
-            <a:ext cx="7828359" cy="1368198"/>
+            <a:off x="1" y="4567988"/>
+            <a:ext cx="10437812" cy="1368198"/>
           </a:xfrm>
           <a:prstGeom prst="rect">
             <a:avLst/>
@@ -2163,8 +2163,8 @@
         </p:nvSpPr>
         <p:spPr>
           <a:xfrm>
-            <a:off x="7939371" y="4567988"/>
-            <a:ext cx="1202248" cy="1368198"/>
+            <a:off x="10585828" y="4567988"/>
+            <a:ext cx="1602997" cy="1368198"/>
           </a:xfrm>
           <a:prstGeom prst="rect">
             <a:avLst/>
@@ -2205,8 +2205,8 @@
         </p:nvSpPr>
         <p:spPr>
           <a:xfrm>
-            <a:off x="845892" y="609598"/>
-            <a:ext cx="6539158" cy="3036061"/>
+            <a:off x="1127856" y="609598"/>
+            <a:ext cx="8718877" cy="3036061"/>
           </a:xfrm>
         </p:spPr>
         <p:txBody>
@@ -2237,8 +2237,8 @@
         </p:nvSpPr>
         <p:spPr>
           <a:xfrm>
-            <a:off x="1051717" y="3653379"/>
-            <a:ext cx="6117434" cy="548968"/>
+            <a:off x="1402289" y="3653379"/>
+            <a:ext cx="8156579" cy="548968"/>
           </a:xfrm>
         </p:spPr>
         <p:txBody>
@@ -2304,8 +2304,8 @@
         </p:nvSpPr>
         <p:spPr>
           <a:xfrm>
-            <a:off x="510242" y="4711616"/>
-            <a:ext cx="7210394" cy="1090789"/>
+            <a:off x="680322" y="4711617"/>
+            <a:ext cx="9613859" cy="1090789"/>
           </a:xfrm>
         </p:spPr>
         <p:txBody>
@@ -2422,8 +2422,8 @@
         </p:nvSpPr>
         <p:spPr>
           <a:xfrm>
-            <a:off x="8047092" y="4709926"/>
-            <a:ext cx="865613" cy="1090789"/>
+            <a:off x="10729457" y="4709927"/>
+            <a:ext cx="1154151" cy="1090789"/>
           </a:xfrm>
         </p:spPr>
         <p:txBody>
@@ -2452,8 +2452,8 @@
         </p:nvSpPr>
         <p:spPr>
           <a:xfrm>
-            <a:off x="437679" y="748116"/>
-            <a:ext cx="457200" cy="584776"/>
+            <a:off x="583572" y="748116"/>
+            <a:ext cx="609600" cy="584776"/>
           </a:xfrm>
           <a:prstGeom prst="rect">
             <a:avLst/>
@@ -2568,8 +2568,8 @@
         </p:nvSpPr>
         <p:spPr>
           <a:xfrm>
-            <a:off x="7247107" y="3033524"/>
-            <a:ext cx="457200" cy="584776"/>
+            <a:off x="9662809" y="3033524"/>
+            <a:ext cx="609600" cy="584776"/>
           </a:xfrm>
           <a:prstGeom prst="rect">
             <a:avLst/>
@@ -2729,8 +2729,8 @@
         </p:blipFill>
         <p:spPr>
           <a:xfrm>
-            <a:off x="1" y="5928628"/>
-            <a:ext cx="7828359" cy="321164"/>
+            <a:off x="2" y="5928628"/>
+            <a:ext cx="10437812" cy="321164"/>
           </a:xfrm>
           <a:prstGeom prst="rect">
             <a:avLst/>
@@ -2759,8 +2759,8 @@
         </p:blipFill>
         <p:spPr>
           <a:xfrm>
-            <a:off x="7939370" y="5929622"/>
-            <a:ext cx="1202248" cy="144270"/>
+            <a:off x="10585827" y="5929622"/>
+            <a:ext cx="1602997" cy="144270"/>
           </a:xfrm>
           <a:prstGeom prst="rect">
             <a:avLst/>
@@ -2775,8 +2775,8 @@
         </p:nvSpPr>
         <p:spPr bwMode="ltGray">
           <a:xfrm>
-            <a:off x="0" y="4567988"/>
-            <a:ext cx="7828359" cy="1368198"/>
+            <a:off x="1" y="4567988"/>
+            <a:ext cx="10437812" cy="1368198"/>
           </a:xfrm>
           <a:prstGeom prst="rect">
             <a:avLst/>
@@ -2816,8 +2816,8 @@
         </p:nvSpPr>
         <p:spPr>
           <a:xfrm>
-            <a:off x="7939371" y="4567988"/>
-            <a:ext cx="1202248" cy="1368198"/>
+            <a:off x="10585828" y="4567988"/>
+            <a:ext cx="1602997" cy="1368198"/>
           </a:xfrm>
           <a:prstGeom prst="rect">
             <a:avLst/>
@@ -2858,8 +2858,8 @@
         </p:nvSpPr>
         <p:spPr>
           <a:xfrm>
-            <a:off x="510239" y="4711616"/>
-            <a:ext cx="7210397" cy="588535"/>
+            <a:off x="680319" y="4711617"/>
+            <a:ext cx="9613863" cy="588535"/>
           </a:xfrm>
         </p:spPr>
         <p:txBody>
@@ -2890,8 +2890,8 @@
         </p:nvSpPr>
         <p:spPr>
           <a:xfrm>
-            <a:off x="510240" y="5300150"/>
-            <a:ext cx="7210397" cy="502255"/>
+            <a:off x="680320" y="5300151"/>
+            <a:ext cx="9613863" cy="502255"/>
           </a:xfrm>
         </p:spPr>
         <p:txBody>
@@ -3006,8 +3006,8 @@
         </p:nvSpPr>
         <p:spPr>
           <a:xfrm>
-            <a:off x="8047092" y="4709926"/>
-            <a:ext cx="865613" cy="1090789"/>
+            <a:off x="10729457" y="4709927"/>
+            <a:ext cx="1154151" cy="1090789"/>
           </a:xfrm>
         </p:spPr>
         <p:txBody>
@@ -3081,8 +3081,8 @@
         </p:blipFill>
         <p:spPr>
           <a:xfrm>
-            <a:off x="1" y="1970240"/>
-            <a:ext cx="7828359" cy="321164"/>
+            <a:off x="2" y="1970240"/>
+            <a:ext cx="10437812" cy="321164"/>
           </a:xfrm>
           <a:prstGeom prst="rect">
             <a:avLst/>
@@ -3111,8 +3111,8 @@
         </p:blipFill>
         <p:spPr>
           <a:xfrm>
-            <a:off x="7939370" y="1971234"/>
-            <a:ext cx="1202248" cy="144270"/>
+            <a:off x="10585827" y="1971234"/>
+            <a:ext cx="1602997" cy="144270"/>
           </a:xfrm>
           <a:prstGeom prst="rect">
             <a:avLst/>
@@ -3127,8 +3127,8 @@
         </p:nvSpPr>
         <p:spPr bwMode="ltGray">
           <a:xfrm>
-            <a:off x="0" y="609600"/>
-            <a:ext cx="7828359" cy="1368198"/>
+            <a:off x="1" y="609600"/>
+            <a:ext cx="10437812" cy="1368198"/>
           </a:xfrm>
           <a:prstGeom prst="rect">
             <a:avLst/>
@@ -3168,8 +3168,8 @@
         </p:nvSpPr>
         <p:spPr>
           <a:xfrm>
-            <a:off x="7939371" y="609600"/>
-            <a:ext cx="1202248" cy="1368198"/>
+            <a:off x="10585828" y="609600"/>
+            <a:ext cx="1602997" cy="1368198"/>
           </a:xfrm>
           <a:prstGeom prst="rect">
             <a:avLst/>
@@ -3210,8 +3210,8 @@
         </p:nvSpPr>
         <p:spPr>
           <a:xfrm>
-            <a:off x="501916" y="753228"/>
-            <a:ext cx="7218720" cy="1080938"/>
+            <a:off x="669221" y="753228"/>
+            <a:ext cx="9624960" cy="1080938"/>
           </a:xfrm>
         </p:spPr>
         <p:txBody>
@@ -3238,8 +3238,8 @@
         </p:nvSpPr>
         <p:spPr>
           <a:xfrm>
-            <a:off x="495709" y="2336873"/>
-            <a:ext cx="2302526" cy="576262"/>
+            <a:off x="660945" y="2336873"/>
+            <a:ext cx="3070035" cy="576262"/>
           </a:xfrm>
         </p:spPr>
         <p:txBody>
@@ -3309,8 +3309,8 @@
         </p:nvSpPr>
         <p:spPr>
           <a:xfrm>
-            <a:off x="510241" y="3022674"/>
-            <a:ext cx="2287277" cy="2913513"/>
+            <a:off x="680322" y="3022674"/>
+            <a:ext cx="3049703" cy="2913513"/>
           </a:xfrm>
         </p:spPr>
         <p:txBody>
@@ -3376,8 +3376,8 @@
         </p:nvSpPr>
         <p:spPr>
           <a:xfrm>
-            <a:off x="2967019" y="2336873"/>
-            <a:ext cx="2297430" cy="576262"/>
+            <a:off x="3956025" y="2336873"/>
+            <a:ext cx="3063240" cy="576262"/>
           </a:xfrm>
         </p:spPr>
         <p:txBody>
@@ -3447,8 +3447,8 @@
         </p:nvSpPr>
         <p:spPr>
           <a:xfrm>
-            <a:off x="2959103" y="3022674"/>
-            <a:ext cx="2297430" cy="2913513"/>
+            <a:off x="3945471" y="3022674"/>
+            <a:ext cx="3063240" cy="2913513"/>
           </a:xfrm>
         </p:spPr>
         <p:txBody>
@@ -3514,8 +3514,8 @@
         </p:nvSpPr>
         <p:spPr>
           <a:xfrm>
-            <a:off x="5418117" y="2336873"/>
-            <a:ext cx="2302519" cy="576262"/>
+            <a:off x="7224157" y="2336873"/>
+            <a:ext cx="3070025" cy="576262"/>
           </a:xfrm>
         </p:spPr>
         <p:txBody>
@@ -3585,8 +3585,8 @@
         </p:nvSpPr>
         <p:spPr>
           <a:xfrm>
-            <a:off x="5418117" y="3022674"/>
-            <a:ext cx="2302519" cy="2913513"/>
+            <a:off x="7224157" y="3022674"/>
+            <a:ext cx="3070025" cy="2913513"/>
           </a:xfrm>
         </p:spPr>
         <p:txBody>
@@ -3773,8 +3773,8 @@
         </p:blipFill>
         <p:spPr>
           <a:xfrm>
-            <a:off x="1" y="1970240"/>
-            <a:ext cx="7828359" cy="321164"/>
+            <a:off x="2" y="1970240"/>
+            <a:ext cx="10437812" cy="321164"/>
           </a:xfrm>
           <a:prstGeom prst="rect">
             <a:avLst/>
@@ -3803,8 +3803,8 @@
         </p:blipFill>
         <p:spPr>
           <a:xfrm>
-            <a:off x="7939370" y="1971234"/>
-            <a:ext cx="1202248" cy="144270"/>
+            <a:off x="10585827" y="1971234"/>
+            <a:ext cx="1602997" cy="144270"/>
           </a:xfrm>
           <a:prstGeom prst="rect">
             <a:avLst/>
@@ -3819,8 +3819,8 @@
         </p:nvSpPr>
         <p:spPr bwMode="ltGray">
           <a:xfrm>
-            <a:off x="0" y="609600"/>
-            <a:ext cx="7828359" cy="1368198"/>
+            <a:off x="1" y="609600"/>
+            <a:ext cx="10437812" cy="1368198"/>
           </a:xfrm>
           <a:prstGeom prst="rect">
             <a:avLst/>
@@ -3860,8 +3860,8 @@
         </p:nvSpPr>
         <p:spPr>
           <a:xfrm>
-            <a:off x="7939371" y="609600"/>
-            <a:ext cx="1202248" cy="1368198"/>
+            <a:off x="10585828" y="609600"/>
+            <a:ext cx="1602997" cy="1368198"/>
           </a:xfrm>
           <a:prstGeom prst="rect">
             <a:avLst/>
@@ -3902,8 +3902,8 @@
         </p:nvSpPr>
         <p:spPr>
           <a:xfrm>
-            <a:off x="510241" y="753228"/>
-            <a:ext cx="7210395" cy="1080938"/>
+            <a:off x="680322" y="753228"/>
+            <a:ext cx="9613860" cy="1080938"/>
           </a:xfrm>
         </p:spPr>
         <p:txBody>
@@ -3930,8 +3930,8 @@
         </p:nvSpPr>
         <p:spPr>
           <a:xfrm>
-            <a:off x="510239" y="4297503"/>
-            <a:ext cx="2287279" cy="576262"/>
+            <a:off x="680320" y="4297503"/>
+            <a:ext cx="3049705" cy="576262"/>
           </a:xfrm>
         </p:spPr>
         <p:txBody>
@@ -4001,8 +4001,8 @@
         </p:nvSpPr>
         <p:spPr>
           <a:xfrm>
-            <a:off x="510239" y="2336873"/>
-            <a:ext cx="2287279" cy="1524000"/>
+            <a:off x="680320" y="2336873"/>
+            <a:ext cx="3049705" cy="1524000"/>
           </a:xfrm>
           <a:prstGeom prst="roundRect">
             <a:avLst>
@@ -4080,8 +4080,8 @@
         </p:nvSpPr>
         <p:spPr>
           <a:xfrm>
-            <a:off x="510239" y="4873765"/>
-            <a:ext cx="2287279" cy="1062422"/>
+            <a:off x="680320" y="4873765"/>
+            <a:ext cx="3049705" cy="1062422"/>
           </a:xfrm>
         </p:spPr>
         <p:txBody>
@@ -4147,8 +4147,8 @@
         </p:nvSpPr>
         <p:spPr>
           <a:xfrm>
-            <a:off x="2959103" y="4297503"/>
-            <a:ext cx="2297430" cy="576262"/>
+            <a:off x="3945471" y="4297503"/>
+            <a:ext cx="3063240" cy="576262"/>
           </a:xfrm>
         </p:spPr>
         <p:txBody>
@@ -4218,8 +4218,8 @@
         </p:nvSpPr>
         <p:spPr>
           <a:xfrm>
-            <a:off x="2959103" y="2336873"/>
-            <a:ext cx="2297430" cy="1524000"/>
+            <a:off x="3945471" y="2336873"/>
+            <a:ext cx="3063240" cy="1524000"/>
           </a:xfrm>
           <a:prstGeom prst="roundRect">
             <a:avLst>
@@ -4297,8 +4297,8 @@
         </p:nvSpPr>
         <p:spPr>
           <a:xfrm>
-            <a:off x="2958088" y="4873764"/>
-            <a:ext cx="2300473" cy="1062422"/>
+            <a:off x="3944118" y="4873764"/>
+            <a:ext cx="3067297" cy="1062422"/>
           </a:xfrm>
         </p:spPr>
         <p:txBody>
@@ -4364,8 +4364,8 @@
         </p:nvSpPr>
         <p:spPr>
           <a:xfrm>
-            <a:off x="5423009" y="4297503"/>
-            <a:ext cx="2297629" cy="576262"/>
+            <a:off x="7230680" y="4297503"/>
+            <a:ext cx="3063505" cy="576262"/>
           </a:xfrm>
         </p:spPr>
         <p:txBody>
@@ -4435,8 +4435,8 @@
         </p:nvSpPr>
         <p:spPr>
           <a:xfrm>
-            <a:off x="5423008" y="2336873"/>
-            <a:ext cx="2297629" cy="1524000"/>
+            <a:off x="7230678" y="2336873"/>
+            <a:ext cx="3063505" cy="1524000"/>
           </a:xfrm>
           <a:prstGeom prst="roundRect">
             <a:avLst>
@@ -4514,8 +4514,8 @@
         </p:nvSpPr>
         <p:spPr>
           <a:xfrm>
-            <a:off x="5422915" y="4873762"/>
-            <a:ext cx="2300672" cy="1062422"/>
+            <a:off x="7230553" y="4873762"/>
+            <a:ext cx="3067563" cy="1062422"/>
           </a:xfrm>
         </p:spPr>
         <p:txBody>
@@ -4702,8 +4702,8 @@
         </p:blipFill>
         <p:spPr>
           <a:xfrm>
-            <a:off x="1" y="1970240"/>
-            <a:ext cx="7828359" cy="321164"/>
+            <a:off x="2" y="1970240"/>
+            <a:ext cx="10437812" cy="321164"/>
           </a:xfrm>
           <a:prstGeom prst="rect">
             <a:avLst/>
@@ -4732,8 +4732,8 @@
         </p:blipFill>
         <p:spPr>
           <a:xfrm>
-            <a:off x="7939370" y="1971234"/>
-            <a:ext cx="1202248" cy="144270"/>
+            <a:off x="10585827" y="1971234"/>
+            <a:ext cx="1602997" cy="144270"/>
           </a:xfrm>
           <a:prstGeom prst="rect">
             <a:avLst/>
@@ -4748,8 +4748,8 @@
         </p:nvSpPr>
         <p:spPr bwMode="ltGray">
           <a:xfrm>
-            <a:off x="0" y="609600"/>
-            <a:ext cx="7828359" cy="1368198"/>
+            <a:off x="1" y="609600"/>
+            <a:ext cx="10437812" cy="1368198"/>
           </a:xfrm>
           <a:prstGeom prst="rect">
             <a:avLst/>
@@ -4789,8 +4789,8 @@
         </p:nvSpPr>
         <p:spPr>
           <a:xfrm>
-            <a:off x="7939371" y="609600"/>
-            <a:ext cx="1202248" cy="1368198"/>
+            <a:off x="10585828" y="609600"/>
+            <a:ext cx="1602997" cy="1368198"/>
           </a:xfrm>
           <a:prstGeom prst="rect">
             <a:avLst/>
@@ -5019,8 +5019,8 @@
         </p:nvSpPr>
         <p:spPr bwMode="ltGray">
           <a:xfrm rot="5400000">
-            <a:off x="5448782" y="2040420"/>
-            <a:ext cx="5106988" cy="1026149"/>
+            <a:off x="8116207" y="1869395"/>
+            <a:ext cx="5106988" cy="1368199"/>
           </a:xfrm>
           <a:prstGeom prst="rect">
             <a:avLst/>
@@ -5060,8 +5060,8 @@
         </p:nvSpPr>
         <p:spPr>
           <a:xfrm rot="5400000">
-            <a:off x="7200777" y="5543428"/>
-            <a:ext cx="1602997" cy="1026149"/>
+            <a:off x="9868203" y="5372404"/>
+            <a:ext cx="1602997" cy="1368199"/>
           </a:xfrm>
           <a:prstGeom prst="rect">
             <a:avLst/>
@@ -5102,8 +5102,8 @@
         </p:nvSpPr>
         <p:spPr>
           <a:xfrm>
-            <a:off x="7596923" y="609597"/>
-            <a:ext cx="805352" cy="4353760"/>
+            <a:off x="10129231" y="609597"/>
+            <a:ext cx="1073803" cy="4353760"/>
           </a:xfrm>
         </p:spPr>
         <p:txBody>
@@ -5130,8 +5130,8 @@
         </p:nvSpPr>
         <p:spPr>
           <a:xfrm>
-            <a:off x="510241" y="609598"/>
-            <a:ext cx="6652503" cy="5326589"/>
+            <a:off x="680322" y="609599"/>
+            <a:ext cx="8870004" cy="5326589"/>
           </a:xfrm>
         </p:spPr>
         <p:txBody>
@@ -5187,8 +5187,8 @@
         </p:nvSpPr>
         <p:spPr>
           <a:xfrm>
-            <a:off x="5105344" y="5936188"/>
-            <a:ext cx="2057400" cy="365125"/>
+            <a:off x="6807125" y="5936189"/>
+            <a:ext cx="2743200" cy="365125"/>
           </a:xfrm>
         </p:spPr>
         <p:txBody>
@@ -5221,8 +5221,8 @@
         </p:nvSpPr>
         <p:spPr>
           <a:xfrm>
-            <a:off x="510241" y="5936189"/>
-            <a:ext cx="4595104" cy="365125"/>
+            <a:off x="680321" y="5936190"/>
+            <a:ext cx="6126805" cy="365125"/>
           </a:xfrm>
         </p:spPr>
         <p:txBody>
@@ -5251,8 +5251,8 @@
         </p:nvSpPr>
         <p:spPr>
           <a:xfrm>
-            <a:off x="7573163" y="5398634"/>
-            <a:ext cx="865613" cy="1090789"/>
+            <a:off x="10097551" y="5398635"/>
+            <a:ext cx="1154151" cy="1090789"/>
           </a:xfrm>
         </p:spPr>
         <p:txBody>
@@ -5329,8 +5329,8 @@
         </p:blipFill>
         <p:spPr>
           <a:xfrm>
-            <a:off x="1" y="1970240"/>
-            <a:ext cx="7828359" cy="321164"/>
+            <a:off x="2" y="1970240"/>
+            <a:ext cx="10437812" cy="321164"/>
           </a:xfrm>
           <a:prstGeom prst="rect">
             <a:avLst/>
@@ -5359,8 +5359,8 @@
         </p:blipFill>
         <p:spPr>
           <a:xfrm>
-            <a:off x="7939370" y="1971234"/>
-            <a:ext cx="1202248" cy="144270"/>
+            <a:off x="10585827" y="1971234"/>
+            <a:ext cx="1602997" cy="144270"/>
           </a:xfrm>
           <a:prstGeom prst="rect">
             <a:avLst/>
@@ -5375,8 +5375,8 @@
         </p:nvSpPr>
         <p:spPr bwMode="ltGray">
           <a:xfrm>
-            <a:off x="0" y="609600"/>
-            <a:ext cx="7828359" cy="1368198"/>
+            <a:off x="1" y="609600"/>
+            <a:ext cx="10437812" cy="1368198"/>
           </a:xfrm>
           <a:prstGeom prst="rect">
             <a:avLst/>
@@ -5411,7 +5411,7 @@
           <a:bodyPr/>
           <a:lstStyle/>
           <a:p>
-            <a:endParaRPr lang="en-US"/>
+            <a:endParaRPr lang="en-US" sz="2800"/>
           </a:p>
         </p:txBody>
       </p:sp>
@@ -5423,8 +5423,8 @@
         </p:nvSpPr>
         <p:spPr>
           <a:xfrm>
-            <a:off x="7939371" y="609600"/>
-            <a:ext cx="1202248" cy="1368198"/>
+            <a:off x="10585828" y="609600"/>
+            <a:ext cx="1602997" cy="1368198"/>
           </a:xfrm>
           <a:prstGeom prst="rect">
             <a:avLst/>
@@ -5456,7 +5456,7 @@
           <a:bodyPr/>
           <a:lstStyle/>
           <a:p>
-            <a:endParaRPr lang="en-US"/>
+            <a:endParaRPr lang="en-US" sz="2800"/>
           </a:p>
         </p:txBody>
       </p:sp>
@@ -5668,7 +5668,7 @@
         <p:spPr>
           <a:xfrm>
             <a:off x="-1" y="4086907"/>
-            <a:ext cx="7828359" cy="321164"/>
+            <a:ext cx="10437812" cy="321164"/>
           </a:xfrm>
           <a:prstGeom prst="rect">
             <a:avLst/>
@@ -5697,8 +5697,8 @@
         </p:blipFill>
         <p:spPr>
           <a:xfrm>
-            <a:off x="7939368" y="4087901"/>
-            <a:ext cx="1202248" cy="144270"/>
+            <a:off x="10585824" y="4087901"/>
+            <a:ext cx="1602997" cy="144270"/>
           </a:xfrm>
           <a:prstGeom prst="rect">
             <a:avLst/>
@@ -5714,7 +5714,7 @@
         <p:spPr bwMode="ltGray">
           <a:xfrm>
             <a:off x="-2" y="2726267"/>
-            <a:ext cx="7828359" cy="1368198"/>
+            <a:ext cx="10437812" cy="1368198"/>
           </a:xfrm>
           <a:prstGeom prst="rect">
             <a:avLst/>
@@ -5754,8 +5754,8 @@
         </p:nvSpPr>
         <p:spPr>
           <a:xfrm>
-            <a:off x="7939369" y="2726267"/>
-            <a:ext cx="1202248" cy="1368198"/>
+            <a:off x="10585826" y="2726267"/>
+            <a:ext cx="1602997" cy="1368198"/>
           </a:xfrm>
           <a:prstGeom prst="rect">
             <a:avLst/>
@@ -5796,8 +5796,8 @@
         </p:nvSpPr>
         <p:spPr>
           <a:xfrm>
-            <a:off x="510241" y="2869895"/>
-            <a:ext cx="7210395" cy="1090788"/>
+            <a:off x="680322" y="2869895"/>
+            <a:ext cx="9613860" cy="1090788"/>
           </a:xfrm>
         </p:spPr>
         <p:txBody>
@@ -5830,8 +5830,8 @@
         </p:nvSpPr>
         <p:spPr>
           <a:xfrm>
-            <a:off x="510241" y="4232172"/>
-            <a:ext cx="7210395" cy="1704017"/>
+            <a:off x="680322" y="4232173"/>
+            <a:ext cx="9613860" cy="1704017"/>
           </a:xfrm>
         </p:spPr>
         <p:txBody>
@@ -6002,8 +6002,8 @@
         </p:nvSpPr>
         <p:spPr>
           <a:xfrm>
-            <a:off x="8047092" y="2869896"/>
-            <a:ext cx="865613" cy="1090789"/>
+            <a:off x="10729457" y="2869897"/>
+            <a:ext cx="1154151" cy="1090789"/>
           </a:xfrm>
         </p:spPr>
         <p:txBody>
@@ -6076,8 +6076,8 @@
         </p:blipFill>
         <p:spPr>
           <a:xfrm>
-            <a:off x="1" y="1970240"/>
-            <a:ext cx="7828359" cy="321164"/>
+            <a:off x="2" y="1970240"/>
+            <a:ext cx="10437812" cy="321164"/>
           </a:xfrm>
           <a:prstGeom prst="rect">
             <a:avLst/>
@@ -6106,8 +6106,8 @@
         </p:blipFill>
         <p:spPr>
           <a:xfrm>
-            <a:off x="7939370" y="1971234"/>
-            <a:ext cx="1202248" cy="144270"/>
+            <a:off x="10585827" y="1971234"/>
+            <a:ext cx="1602997" cy="144270"/>
           </a:xfrm>
           <a:prstGeom prst="rect">
             <a:avLst/>
@@ -6122,8 +6122,8 @@
         </p:nvSpPr>
         <p:spPr bwMode="ltGray">
           <a:xfrm>
-            <a:off x="0" y="609600"/>
-            <a:ext cx="7828359" cy="1368198"/>
+            <a:off x="1" y="609600"/>
+            <a:ext cx="10437812" cy="1368198"/>
           </a:xfrm>
           <a:prstGeom prst="rect">
             <a:avLst/>
@@ -6163,8 +6163,8 @@
         </p:nvSpPr>
         <p:spPr>
           <a:xfrm>
-            <a:off x="7939371" y="609600"/>
-            <a:ext cx="1202248" cy="1368198"/>
+            <a:off x="10585828" y="609600"/>
+            <a:ext cx="1602997" cy="1368198"/>
           </a:xfrm>
           <a:prstGeom prst="rect">
             <a:avLst/>
@@ -6228,8 +6228,8 @@
         </p:nvSpPr>
         <p:spPr>
           <a:xfrm>
-            <a:off x="510240" y="2336873"/>
-            <a:ext cx="3523769" cy="3599316"/>
+            <a:off x="680321" y="2336873"/>
+            <a:ext cx="4698359" cy="3599316"/>
           </a:xfrm>
         </p:spPr>
         <p:txBody>
@@ -6285,8 +6285,8 @@
         </p:nvSpPr>
         <p:spPr>
           <a:xfrm>
-            <a:off x="4195592" y="2336873"/>
-            <a:ext cx="3525044" cy="3599316"/>
+            <a:off x="5594123" y="2336873"/>
+            <a:ext cx="4700059" cy="3599316"/>
           </a:xfrm>
         </p:spPr>
         <p:txBody>
@@ -6462,8 +6462,8 @@
         </p:blipFill>
         <p:spPr>
           <a:xfrm>
-            <a:off x="1" y="1970240"/>
-            <a:ext cx="7828359" cy="321164"/>
+            <a:off x="2" y="1970240"/>
+            <a:ext cx="10437812" cy="321164"/>
           </a:xfrm>
           <a:prstGeom prst="rect">
             <a:avLst/>
@@ -6492,8 +6492,8 @@
         </p:blipFill>
         <p:spPr>
           <a:xfrm>
-            <a:off x="7939370" y="1971234"/>
-            <a:ext cx="1202248" cy="144270"/>
+            <a:off x="10585827" y="1971234"/>
+            <a:ext cx="1602997" cy="144270"/>
           </a:xfrm>
           <a:prstGeom prst="rect">
             <a:avLst/>
@@ -6508,8 +6508,8 @@
         </p:nvSpPr>
         <p:spPr bwMode="ltGray">
           <a:xfrm>
-            <a:off x="0" y="609600"/>
-            <a:ext cx="7828359" cy="1368198"/>
+            <a:off x="1" y="609600"/>
+            <a:ext cx="10437812" cy="1368198"/>
           </a:xfrm>
           <a:prstGeom prst="rect">
             <a:avLst/>
@@ -6549,8 +6549,8 @@
         </p:nvSpPr>
         <p:spPr>
           <a:xfrm>
-            <a:off x="7939371" y="609600"/>
-            <a:ext cx="1202248" cy="1368198"/>
+            <a:off x="10585828" y="609600"/>
+            <a:ext cx="1602997" cy="1368198"/>
           </a:xfrm>
           <a:prstGeom prst="rect">
             <a:avLst/>
@@ -6591,8 +6591,8 @@
         </p:nvSpPr>
         <p:spPr>
           <a:xfrm>
-            <a:off x="510240" y="753230"/>
-            <a:ext cx="7210397" cy="1080937"/>
+            <a:off x="680320" y="753231"/>
+            <a:ext cx="9613863" cy="1080937"/>
           </a:xfrm>
         </p:spPr>
         <p:txBody>
@@ -6619,8 +6619,8 @@
         </p:nvSpPr>
         <p:spPr>
           <a:xfrm>
-            <a:off x="679763" y="2336874"/>
-            <a:ext cx="3354245" cy="693135"/>
+            <a:off x="906351" y="2336875"/>
+            <a:ext cx="4472327" cy="693135"/>
           </a:xfrm>
         </p:spPr>
         <p:txBody>
@@ -6684,8 +6684,8 @@
         </p:nvSpPr>
         <p:spPr>
           <a:xfrm>
-            <a:off x="510242" y="3030009"/>
-            <a:ext cx="3523766" cy="2906179"/>
+            <a:off x="680323" y="3030010"/>
+            <a:ext cx="4698355" cy="2906179"/>
           </a:xfrm>
         </p:spPr>
         <p:txBody>
@@ -6741,8 +6741,8 @@
         </p:nvSpPr>
         <p:spPr>
           <a:xfrm>
-            <a:off x="4365116" y="2336873"/>
-            <a:ext cx="3355521" cy="692076"/>
+            <a:off x="5820155" y="2336873"/>
+            <a:ext cx="4474028" cy="692076"/>
           </a:xfrm>
         </p:spPr>
         <p:txBody>
@@ -6806,8 +6806,8 @@
         </p:nvSpPr>
         <p:spPr>
           <a:xfrm>
-            <a:off x="4195593" y="3030009"/>
-            <a:ext cx="3525044" cy="2906179"/>
+            <a:off x="5594124" y="3030010"/>
+            <a:ext cx="4700059" cy="2906179"/>
           </a:xfrm>
         </p:spPr>
         <p:txBody>
@@ -6983,8 +6983,8 @@
         </p:blipFill>
         <p:spPr>
           <a:xfrm>
-            <a:off x="1" y="1970240"/>
-            <a:ext cx="7828359" cy="321164"/>
+            <a:off x="2" y="1970240"/>
+            <a:ext cx="10437812" cy="321164"/>
           </a:xfrm>
           <a:prstGeom prst="rect">
             <a:avLst/>
@@ -7013,8 +7013,8 @@
         </p:blipFill>
         <p:spPr>
           <a:xfrm>
-            <a:off x="7939370" y="1971234"/>
-            <a:ext cx="1202248" cy="144270"/>
+            <a:off x="10585827" y="1971234"/>
+            <a:ext cx="1602997" cy="144270"/>
           </a:xfrm>
           <a:prstGeom prst="rect">
             <a:avLst/>
@@ -7029,8 +7029,8 @@
         </p:nvSpPr>
         <p:spPr bwMode="ltGray">
           <a:xfrm>
-            <a:off x="0" y="609600"/>
-            <a:ext cx="7828359" cy="1368198"/>
+            <a:off x="1" y="609600"/>
+            <a:ext cx="10437812" cy="1368198"/>
           </a:xfrm>
           <a:prstGeom prst="rect">
             <a:avLst/>
@@ -7065,7 +7065,7 @@
           <a:bodyPr/>
           <a:lstStyle/>
           <a:p>
-            <a:endParaRPr lang="en-US"/>
+            <a:endParaRPr lang="en-US" sz="2800"/>
           </a:p>
         </p:txBody>
       </p:sp>
@@ -7077,8 +7077,8 @@
         </p:nvSpPr>
         <p:spPr>
           <a:xfrm>
-            <a:off x="7939371" y="609600"/>
-            <a:ext cx="1202248" cy="1368198"/>
+            <a:off x="10585828" y="609600"/>
+            <a:ext cx="1602997" cy="1368198"/>
           </a:xfrm>
           <a:prstGeom prst="rect">
             <a:avLst/>
@@ -7110,7 +7110,7 @@
           <a:bodyPr/>
           <a:lstStyle/>
           <a:p>
-            <a:endParaRPr lang="en-US"/>
+            <a:endParaRPr lang="en-US" sz="2800"/>
           </a:p>
         </p:txBody>
       </p:sp>
@@ -7269,8 +7269,8 @@
         </p:blipFill>
         <p:spPr>
           <a:xfrm>
-            <a:off x="7939370" y="1971234"/>
-            <a:ext cx="1202248" cy="144270"/>
+            <a:off x="10585827" y="1971234"/>
+            <a:ext cx="1602997" cy="144270"/>
           </a:xfrm>
           <a:prstGeom prst="rect">
             <a:avLst/>
@@ -7285,8 +7285,8 @@
         </p:nvSpPr>
         <p:spPr>
           <a:xfrm>
-            <a:off x="7939371" y="609600"/>
-            <a:ext cx="1202248" cy="1368198"/>
+            <a:off x="10585828" y="609600"/>
+            <a:ext cx="1602997" cy="1368198"/>
           </a:xfrm>
           <a:prstGeom prst="rect">
             <a:avLst/>
@@ -7318,7 +7318,7 @@
           <a:bodyPr/>
           <a:lstStyle/>
           <a:p>
-            <a:endParaRPr lang="en-US"/>
+            <a:endParaRPr lang="en-US" sz="2800"/>
           </a:p>
         </p:txBody>
       </p:sp>
@@ -7454,8 +7454,8 @@
         </p:blipFill>
         <p:spPr>
           <a:xfrm>
-            <a:off x="1" y="1970240"/>
-            <a:ext cx="7828359" cy="321164"/>
+            <a:off x="2" y="1970240"/>
+            <a:ext cx="10437812" cy="321164"/>
           </a:xfrm>
           <a:prstGeom prst="rect">
             <a:avLst/>
@@ -7484,8 +7484,8 @@
         </p:blipFill>
         <p:spPr>
           <a:xfrm>
-            <a:off x="7939370" y="1971234"/>
-            <a:ext cx="1202248" cy="144270"/>
+            <a:off x="10585827" y="1971234"/>
+            <a:ext cx="1602997" cy="144270"/>
           </a:xfrm>
           <a:prstGeom prst="rect">
             <a:avLst/>
@@ -7500,8 +7500,8 @@
         </p:nvSpPr>
         <p:spPr bwMode="ltGray">
           <a:xfrm>
-            <a:off x="0" y="609600"/>
-            <a:ext cx="7828359" cy="1368198"/>
+            <a:off x="1" y="609600"/>
+            <a:ext cx="10437812" cy="1368198"/>
           </a:xfrm>
           <a:prstGeom prst="rect">
             <a:avLst/>
@@ -7541,8 +7541,8 @@
         </p:nvSpPr>
         <p:spPr>
           <a:xfrm>
-            <a:off x="7939371" y="609600"/>
-            <a:ext cx="1202248" cy="1368198"/>
+            <a:off x="10585828" y="609600"/>
+            <a:ext cx="1602997" cy="1368198"/>
           </a:xfrm>
           <a:prstGeom prst="rect">
             <a:avLst/>
@@ -7583,8 +7583,8 @@
         </p:nvSpPr>
         <p:spPr>
           <a:xfrm>
-            <a:off x="510241" y="753227"/>
-            <a:ext cx="7210394" cy="1080940"/>
+            <a:off x="680321" y="753227"/>
+            <a:ext cx="9613859" cy="1080940"/>
           </a:xfrm>
         </p:spPr>
         <p:txBody>
@@ -7617,8 +7617,8 @@
         </p:nvSpPr>
         <p:spPr>
           <a:xfrm>
-            <a:off x="3514385" y="2336874"/>
-            <a:ext cx="4206252" cy="3599313"/>
+            <a:off x="4685847" y="2336875"/>
+            <a:ext cx="5608336" cy="3599313"/>
           </a:xfrm>
         </p:spPr>
         <p:txBody>
@@ -7674,8 +7674,8 @@
         </p:nvSpPr>
         <p:spPr>
           <a:xfrm>
-            <a:off x="510241" y="2336873"/>
-            <a:ext cx="2842559" cy="3599317"/>
+            <a:off x="680322" y="2336874"/>
+            <a:ext cx="3790079" cy="3599317"/>
           </a:xfrm>
         </p:spPr>
         <p:txBody>
@@ -7862,8 +7862,8 @@
         </p:blipFill>
         <p:spPr>
           <a:xfrm>
-            <a:off x="1" y="1970240"/>
-            <a:ext cx="7828359" cy="321164"/>
+            <a:off x="2" y="1970240"/>
+            <a:ext cx="10437812" cy="321164"/>
           </a:xfrm>
           <a:prstGeom prst="rect">
             <a:avLst/>
@@ -7892,8 +7892,8 @@
         </p:blipFill>
         <p:spPr>
           <a:xfrm>
-            <a:off x="7939370" y="1971234"/>
-            <a:ext cx="1202248" cy="144270"/>
+            <a:off x="10585827" y="1971234"/>
+            <a:ext cx="1602997" cy="144270"/>
           </a:xfrm>
           <a:prstGeom prst="rect">
             <a:avLst/>
@@ -7908,8 +7908,8 @@
         </p:nvSpPr>
         <p:spPr bwMode="ltGray">
           <a:xfrm>
-            <a:off x="0" y="609600"/>
-            <a:ext cx="7828359" cy="1368198"/>
+            <a:off x="1" y="609600"/>
+            <a:ext cx="10437812" cy="1368198"/>
           </a:xfrm>
           <a:prstGeom prst="rect">
             <a:avLst/>
@@ -7949,8 +7949,8 @@
         </p:nvSpPr>
         <p:spPr>
           <a:xfrm>
-            <a:off x="7939371" y="609600"/>
-            <a:ext cx="1202248" cy="1368198"/>
+            <a:off x="10585828" y="609600"/>
+            <a:ext cx="1602997" cy="1368198"/>
           </a:xfrm>
           <a:prstGeom prst="rect">
             <a:avLst/>
@@ -7991,8 +7991,8 @@
         </p:nvSpPr>
         <p:spPr>
           <a:xfrm>
-            <a:off x="510242" y="753228"/>
-            <a:ext cx="7210393" cy="1080938"/>
+            <a:off x="680323" y="753228"/>
+            <a:ext cx="9613857" cy="1080938"/>
           </a:xfrm>
         </p:spPr>
         <p:txBody>
@@ -8025,8 +8025,8 @@
         </p:nvSpPr>
         <p:spPr>
           <a:xfrm>
-            <a:off x="3651250" y="2336874"/>
-            <a:ext cx="4069387" cy="3599312"/>
+            <a:off x="4868334" y="2336874"/>
+            <a:ext cx="5425849" cy="3599312"/>
           </a:xfrm>
           <a:noFill/>
           <a:ln>
@@ -8101,8 +8101,8 @@
         </p:nvSpPr>
         <p:spPr>
           <a:xfrm>
-            <a:off x="510242" y="2336874"/>
-            <a:ext cx="2907192" cy="3599315"/>
+            <a:off x="680323" y="2336875"/>
+            <a:ext cx="3876256" cy="3599315"/>
           </a:xfrm>
         </p:spPr>
         <p:txBody>
@@ -8296,7 +8296,7 @@
         <p:spPr>
           <a:xfrm>
             <a:off x="0" y="0"/>
-            <a:ext cx="9144000" cy="6858000"/>
+            <a:ext cx="12192000" cy="6858000"/>
           </a:xfrm>
           <a:prstGeom prst="rect">
             <a:avLst/>
@@ -8315,8 +8315,8 @@
         </p:nvSpPr>
         <p:spPr>
           <a:xfrm>
-            <a:off x="510241" y="753228"/>
-            <a:ext cx="7210396" cy="1080938"/>
+            <a:off x="680321" y="753228"/>
+            <a:ext cx="9613861" cy="1080938"/>
           </a:xfrm>
           <a:prstGeom prst="rect">
             <a:avLst/>
@@ -8348,8 +8348,8 @@
         </p:nvSpPr>
         <p:spPr>
           <a:xfrm>
-            <a:off x="510241" y="2336873"/>
-            <a:ext cx="7210396" cy="3599316"/>
+            <a:off x="680321" y="2336873"/>
+            <a:ext cx="9613861" cy="3599316"/>
           </a:xfrm>
           <a:prstGeom prst="rect">
             <a:avLst/>
@@ -8410,8 +8410,8 @@
         </p:nvSpPr>
         <p:spPr>
           <a:xfrm>
-            <a:off x="5663236" y="5936188"/>
-            <a:ext cx="2057400" cy="365125"/>
+            <a:off x="7550981" y="5936189"/>
+            <a:ext cx="2743200" cy="365125"/>
           </a:xfrm>
           <a:prstGeom prst="rect">
             <a:avLst/>
@@ -8457,8 +8457,8 @@
         </p:nvSpPr>
         <p:spPr>
           <a:xfrm>
-            <a:off x="510241" y="5936189"/>
-            <a:ext cx="5152995" cy="365125"/>
+            <a:off x="680322" y="5936190"/>
+            <a:ext cx="6870660" cy="365125"/>
           </a:xfrm>
           <a:prstGeom prst="rect">
             <a:avLst/>
@@ -8497,8 +8497,8 @@
         </p:nvSpPr>
         <p:spPr>
           <a:xfrm>
-            <a:off x="8047092" y="753228"/>
-            <a:ext cx="865613" cy="1090789"/>
+            <a:off x="10729457" y="753228"/>
+            <a:ext cx="1154151" cy="1090789"/>
           </a:xfrm>
           <a:prstGeom prst="rect">
             <a:avLst/>
@@ -8880,14 +8880,14 @@
           <a:ln/>
           <a:extLst>
             <a:ext uri="{909E8E84-426E-40dd-AFC4-6F175D3DCCD1}">
-              <a14:hiddenFill xmlns:a14="http://schemas.microsoft.com/office/drawing/2010/main" xmlns="">
+              <a14:hiddenFill xmlns="" xmlns:a14="http://schemas.microsoft.com/office/drawing/2010/main">
                 <a:solidFill>
                   <a:srgbClr val="FFFFFF"/>
                 </a:solidFill>
               </a14:hiddenFill>
             </a:ext>
             <a:ext uri="{91240B29-F687-4f45-9708-019B960494DF}">
-              <a14:hiddenLine xmlns:a14="http://schemas.microsoft.com/office/drawing/2010/main" xmlns="" w="9525">
+              <a14:hiddenLine xmlns="" xmlns:a14="http://schemas.microsoft.com/office/drawing/2010/main" w="9525">
                 <a:solidFill>
                   <a:srgbClr val="000000"/>
                 </a:solidFill>
@@ -9028,7 +9028,7 @@
         </p:nvSpPr>
         <p:spPr bwMode="auto">
           <a:xfrm>
-            <a:off x="115888" y="1001713"/>
+            <a:off x="1639889" y="1001713"/>
             <a:ext cx="8910637" cy="641350"/>
           </a:xfrm>
           <a:prstGeom prst="rect">
@@ -9040,14 +9040,14 @@
           </a:ln>
           <a:extLst>
             <a:ext uri="{909E8E84-426E-40dd-AFC4-6F175D3DCCD1}">
-              <a14:hiddenFill xmlns:a14="http://schemas.microsoft.com/office/drawing/2010/main" xmlns="">
+              <a14:hiddenFill xmlns="" xmlns:a14="http://schemas.microsoft.com/office/drawing/2010/main">
                 <a:solidFill>
                   <a:srgbClr val="FFFFFF"/>
                 </a:solidFill>
               </a14:hiddenFill>
             </a:ext>
             <a:ext uri="{91240B29-F687-4f45-9708-019B960494DF}">
-              <a14:hiddenLine xmlns:a14="http://schemas.microsoft.com/office/drawing/2010/main" xmlns="" w="9525">
+              <a14:hiddenLine xmlns="" xmlns:a14="http://schemas.microsoft.com/office/drawing/2010/main" w="9525">
                 <a:solidFill>
                   <a:srgbClr val="000000"/>
                 </a:solidFill>
@@ -9194,7 +9194,7 @@
         </p:nvSpPr>
         <p:spPr bwMode="auto">
           <a:xfrm>
-            <a:off x="176213" y="5164137"/>
+            <a:off x="1700214" y="5164138"/>
             <a:ext cx="8791575" cy="984871"/>
           </a:xfrm>
           <a:prstGeom prst="rect">
@@ -9206,14 +9206,14 @@
           </a:ln>
           <a:extLst>
             <a:ext uri="{909E8E84-426E-40dd-AFC4-6F175D3DCCD1}">
-              <a14:hiddenFill xmlns:a14="http://schemas.microsoft.com/office/drawing/2010/main" xmlns="">
+              <a14:hiddenFill xmlns="" xmlns:a14="http://schemas.microsoft.com/office/drawing/2010/main">
                 <a:solidFill>
                   <a:srgbClr val="FFFFFF"/>
                 </a:solidFill>
               </a14:hiddenFill>
             </a:ext>
             <a:ext uri="{91240B29-F687-4f45-9708-019B960494DF}">
-              <a14:hiddenLine xmlns:a14="http://schemas.microsoft.com/office/drawing/2010/main" xmlns="" w="9525">
+              <a14:hiddenLine xmlns="" xmlns:a14="http://schemas.microsoft.com/office/drawing/2010/main" w="9525">
                 <a:solidFill>
                   <a:srgbClr val="000000"/>
                 </a:solidFill>
@@ -9231,7 +9231,7 @@
             <a:pPr algn="ctr"/>
             <a:r>
               <a:rPr kumimoji="1" lang="en-US" sz="3200" dirty="0"/>
-              <a:t>Topic 13 – Parsers in Haskell</a:t>
+              <a:t>Topic 13.1 – Parsers in Haskell</a:t>
             </a:r>
           </a:p>
           <a:p>
@@ -9263,7 +9263,7 @@
         </p:blipFill>
         <p:spPr bwMode="auto">
           <a:xfrm>
-            <a:off x="3151188" y="2400300"/>
+            <a:off x="4675189" y="2400300"/>
             <a:ext cx="2841625" cy="2006600"/>
           </a:xfrm>
           <a:prstGeom prst="rect">
@@ -9275,14 +9275,14 @@
           </a:ln>
           <a:extLst>
             <a:ext uri="{909E8E84-426E-40dd-AFC4-6F175D3DCCD1}">
-              <a14:hiddenFill xmlns:a14="http://schemas.microsoft.com/office/drawing/2010/main" xmlns="">
+              <a14:hiddenFill xmlns="" xmlns:a14="http://schemas.microsoft.com/office/drawing/2010/main">
                 <a:solidFill>
                   <a:srgbClr val="FFFFFF"/>
                 </a:solidFill>
               </a14:hiddenFill>
             </a:ext>
             <a:ext uri="{91240B29-F687-4f45-9708-019B960494DF}">
-              <a14:hiddenLine xmlns:a14="http://schemas.microsoft.com/office/drawing/2010/main" xmlns="" w="9525">
+              <a14:hiddenLine xmlns="" xmlns:a14="http://schemas.microsoft.com/office/drawing/2010/main" w="9525">
                 <a:solidFill>
                   <a:srgbClr val="000000"/>
                 </a:solidFill>
@@ -9365,7 +9365,7 @@
         </p:nvSpPr>
         <p:spPr>
           <a:xfrm>
-            <a:off x="748128" y="5130453"/>
+            <a:off x="2272129" y="5130453"/>
             <a:ext cx="6734621" cy="1419816"/>
           </a:xfrm>
           <a:solidFill>
@@ -9474,7 +9474,7 @@
         </p:nvSpPr>
         <p:spPr>
           <a:xfrm>
-            <a:off x="662641" y="1986566"/>
+            <a:off x="2186642" y="1986566"/>
             <a:ext cx="6734621" cy="1171258"/>
           </a:xfrm>
           <a:prstGeom prst="rect">
@@ -9660,7 +9660,6 @@
               <a:spcAft>
                 <a:spcPts val="0"/>
               </a:spcAft>
-              <a:buFont typeface="Arial" panose="020B0604020202020204" pitchFamily="34" charset="0"/>
               <a:buNone/>
             </a:pPr>
             <a:r>
@@ -9673,7 +9672,6 @@
               <a:spcAft>
                 <a:spcPts val="0"/>
               </a:spcAft>
-              <a:buFont typeface="Arial" panose="020B0604020202020204" pitchFamily="34" charset="0"/>
               <a:buNone/>
             </a:pPr>
             <a:r>
@@ -9686,7 +9684,6 @@
               <a:spcAft>
                 <a:spcPts val="0"/>
               </a:spcAft>
-              <a:buFont typeface="Arial" panose="020B0604020202020204" pitchFamily="34" charset="0"/>
               <a:buNone/>
             </a:pPr>
             <a:r>
@@ -9711,7 +9708,7 @@
         </p:nvSpPr>
         <p:spPr>
           <a:xfrm>
-            <a:off x="258666" y="3167390"/>
+            <a:off x="1782666" y="3167390"/>
             <a:ext cx="8626668" cy="523220"/>
           </a:xfrm>
           <a:prstGeom prst="rect">
@@ -9755,7 +9752,7 @@
         </p:nvSpPr>
         <p:spPr>
           <a:xfrm>
-            <a:off x="662641" y="3822743"/>
+            <a:off x="2186642" y="3822743"/>
             <a:ext cx="6734621" cy="1171258"/>
           </a:xfrm>
           <a:prstGeom prst="rect">
@@ -9941,7 +9938,6 @@
               <a:spcAft>
                 <a:spcPts val="0"/>
               </a:spcAft>
-              <a:buFont typeface="Arial" panose="020B0604020202020204" pitchFamily="34" charset="0"/>
               <a:buNone/>
             </a:pPr>
             <a:r>
@@ -9954,7 +9950,6 @@
               <a:spcAft>
                 <a:spcPts val="0"/>
               </a:spcAft>
-              <a:buFont typeface="Arial" panose="020B0604020202020204" pitchFamily="34" charset="0"/>
               <a:buNone/>
             </a:pPr>
             <a:r>
@@ -9967,7 +9962,6 @@
               <a:spcAft>
                 <a:spcPts val="0"/>
               </a:spcAft>
-              <a:buFont typeface="Arial" panose="020B0604020202020204" pitchFamily="34" charset="0"/>
               <a:buNone/>
             </a:pPr>
             <a:r>
@@ -9980,7 +9974,6 @@
               <a:spcAft>
                 <a:spcPts val="0"/>
               </a:spcAft>
-              <a:buFont typeface="Arial" panose="020B0604020202020204" pitchFamily="34" charset="0"/>
               <a:buNone/>
             </a:pPr>
             <a:r>
@@ -10924,7 +10917,7 @@
         </p:nvSpPr>
         <p:spPr>
           <a:xfrm>
-            <a:off x="748128" y="2096391"/>
+            <a:off x="4020246" y="2848458"/>
             <a:ext cx="3249936" cy="457696"/>
           </a:xfrm>
           <a:prstGeom prst="rect">
@@ -11142,7 +11135,7 @@
         </p:nvSpPr>
         <p:spPr>
           <a:xfrm>
-            <a:off x="286037" y="2718645"/>
+            <a:off x="1899684" y="3780694"/>
             <a:ext cx="8626668" cy="523220"/>
           </a:xfrm>
           <a:prstGeom prst="rect">
@@ -11474,7 +11467,7 @@
         </p:nvSpPr>
         <p:spPr>
           <a:xfrm>
-            <a:off x="510241" y="2336873"/>
+            <a:off x="2034241" y="2336874"/>
             <a:ext cx="7210396" cy="3120651"/>
           </a:xfrm>
           <a:solidFill>
@@ -11751,7 +11744,7 @@
         </p:nvSpPr>
         <p:spPr>
           <a:xfrm>
-            <a:off x="336194" y="2302657"/>
+            <a:off x="1860194" y="2302658"/>
             <a:ext cx="8229498" cy="483329"/>
           </a:xfrm>
           <a:prstGeom prst="rect">
@@ -11930,10 +11923,7 @@
             </a:lvl9pPr>
           </a:lstStyle>
           <a:p>
-            <a:pPr marL="0" indent="0" fontAlgn="auto">
-              <a:spcAft>
-                <a:spcPts val="0"/>
-              </a:spcAft>
+            <a:pPr marL="0" indent="0">
               <a:buNone/>
             </a:pPr>
             <a:r>
@@ -11946,10 +11936,7 @@
             </a:r>
           </a:p>
           <a:p>
-            <a:pPr marL="0" indent="0" fontAlgn="auto">
-              <a:spcAft>
-                <a:spcPts val="0"/>
-              </a:spcAft>
+            <a:pPr marL="0" indent="0">
               <a:buNone/>
             </a:pPr>
             <a:endParaRPr lang="en-US" dirty="0"/>
@@ -11972,7 +11959,7 @@
         </p:nvSpPr>
         <p:spPr>
           <a:xfrm>
-            <a:off x="385114" y="3155513"/>
+            <a:off x="1909114" y="3155514"/>
             <a:ext cx="3940702" cy="1080939"/>
           </a:xfrm>
           <a:prstGeom prst="rect">
@@ -12155,7 +12142,6 @@
               <a:spcAft>
                 <a:spcPts val="0"/>
               </a:spcAft>
-              <a:buFont typeface="Arial" panose="020B0604020202020204" pitchFamily="34" charset="0"/>
               <a:buNone/>
             </a:pPr>
             <a:r>
@@ -12169,7 +12155,6 @@
               <a:spcAft>
                 <a:spcPts val="0"/>
               </a:spcAft>
-              <a:buFont typeface="Arial" panose="020B0604020202020204" pitchFamily="34" charset="0"/>
               <a:buNone/>
             </a:pPr>
             <a:r>
@@ -12182,7 +12167,6 @@
               <a:spcAft>
                 <a:spcPts val="0"/>
               </a:spcAft>
-              <a:buFont typeface="Arial" panose="020B0604020202020204" pitchFamily="34" charset="0"/>
               <a:buNone/>
             </a:pPr>
             <a:r>
@@ -12203,7 +12187,6 @@
               <a:spcAft>
                 <a:spcPts val="0"/>
               </a:spcAft>
-              <a:buFont typeface="Arial" panose="020B0604020202020204" pitchFamily="34" charset="0"/>
               <a:buNone/>
             </a:pPr>
             <a:endParaRPr lang="en-US" dirty="0"/>
@@ -12226,7 +12209,7 @@
         </p:nvSpPr>
         <p:spPr>
           <a:xfrm>
-            <a:off x="457251" y="4695092"/>
+            <a:off x="1981251" y="4695093"/>
             <a:ext cx="3604796" cy="1336431"/>
           </a:xfrm>
           <a:prstGeom prst="rect">
@@ -12566,7 +12549,7 @@
         </p:nvSpPr>
         <p:spPr>
           <a:xfrm>
-            <a:off x="1230922" y="2762944"/>
+            <a:off x="2754923" y="2762945"/>
             <a:ext cx="5908431" cy="954107"/>
           </a:xfrm>
           <a:prstGeom prst="rect">
@@ -12665,7 +12648,7 @@
         </p:blipFill>
         <p:spPr>
           <a:xfrm>
-            <a:off x="1230922" y="4602080"/>
+            <a:off x="2754923" y="4602080"/>
             <a:ext cx="4579155" cy="756556"/>
           </a:xfrm>
           <a:prstGeom prst="rect">
@@ -12687,7 +12670,7 @@
         </p:nvSpPr>
         <p:spPr>
           <a:xfrm>
-            <a:off x="1336431" y="3897955"/>
+            <a:off x="2860431" y="3897955"/>
             <a:ext cx="1820008" cy="523220"/>
           </a:xfrm>
           <a:prstGeom prst="rect">
@@ -12975,7 +12958,7 @@
         </p:blipFill>
         <p:spPr>
           <a:xfrm>
-            <a:off x="1171136" y="1012380"/>
+            <a:off x="2695136" y="1012380"/>
             <a:ext cx="6359526" cy="4833240"/>
           </a:xfrm>
           <a:prstGeom prst="rect">
@@ -12997,14 +12980,14 @@
         <p:spPr>
           <a:extLst>
             <a:ext uri="{909E8E84-426E-40dd-AFC4-6F175D3DCCD1}">
-              <a14:hiddenFill xmlns="" xmlns:a14="http://schemas.microsoft.com/office/drawing/2010/main">
+              <a14:hiddenFill xmlns:a14="http://schemas.microsoft.com/office/drawing/2010/main" xmlns="">
                 <a:solidFill>
                   <a:srgbClr val="FFFFFF"/>
                 </a:solidFill>
               </a14:hiddenFill>
             </a:ext>
             <a:ext uri="{91240B29-F687-4f45-9708-019B960494DF}">
-              <a14:hiddenLine xmlns="" xmlns:a14="http://schemas.microsoft.com/office/drawing/2010/main" w="9525">
+              <a14:hiddenLine xmlns:a14="http://schemas.microsoft.com/office/drawing/2010/main" xmlns="" w="9525">
                 <a:solidFill>
                   <a:srgbClr val="000000"/>
                 </a:solidFill>
@@ -13195,7 +13178,7 @@
         </p:nvSpPr>
         <p:spPr>
           <a:xfrm>
-            <a:off x="625647" y="5815694"/>
+            <a:off x="2149647" y="5815694"/>
             <a:ext cx="1664208" cy="683046"/>
           </a:xfrm>
           <a:prstGeom prst="rect">
@@ -13215,9 +13198,7 @@
           <a:bodyPr/>
           <a:lstStyle/>
           <a:p>
-            <a:pPr marL="0" indent="0" algn="ctr">
-              <a:buNone/>
-            </a:pPr>
+            <a:pPr algn="ctr"/>
             <a:endParaRPr lang="en-US" sz="1400" b="1" dirty="0">
               <a:solidFill>
                 <a:srgbClr val="FFFFFF"/>
@@ -13228,9 +13209,7 @@
             </a:endParaRPr>
           </a:p>
           <a:p>
-            <a:pPr marL="0" indent="0" algn="ctr">
-              <a:buNone/>
-            </a:pPr>
+            <a:pPr algn="ctr"/>
             <a:r>
               <a:rPr lang="en-US" sz="1400" b="1" dirty="0">
                 <a:solidFill>
@@ -13260,7 +13239,7 @@
         </p:nvSpPr>
         <p:spPr>
           <a:xfrm>
-            <a:off x="5788121" y="5737785"/>
+            <a:off x="7312121" y="5737785"/>
             <a:ext cx="2331720" cy="749808"/>
           </a:xfrm>
           <a:prstGeom prst="rect">
@@ -13299,14 +13278,14 @@
           <a:ln/>
           <a:extLst>
             <a:ext uri="{909E8E84-426E-40dd-AFC4-6F175D3DCCD1}">
-              <a14:hiddenFill xmlns:a14="http://schemas.microsoft.com/office/drawing/2010/main" xmlns="">
+              <a14:hiddenFill xmlns="" xmlns:a14="http://schemas.microsoft.com/office/drawing/2010/main">
                 <a:solidFill>
                   <a:srgbClr val="FFFFFF"/>
                 </a:solidFill>
               </a14:hiddenFill>
             </a:ext>
             <a:ext uri="{91240B29-F687-4f45-9708-019B960494DF}">
-              <a14:hiddenLine xmlns:a14="http://schemas.microsoft.com/office/drawing/2010/main" xmlns="" w="9525">
+              <a14:hiddenLine xmlns="" xmlns:a14="http://schemas.microsoft.com/office/drawing/2010/main" w="9525">
                 <a:solidFill>
                   <a:srgbClr val="000000"/>
                 </a:solidFill>
@@ -13451,7 +13430,7 @@
         </p:nvSpPr>
         <p:spPr>
           <a:xfrm>
-            <a:off x="510241" y="1065481"/>
+            <a:off x="2034242" y="1065482"/>
             <a:ext cx="3276603" cy="466281"/>
           </a:xfrm>
           <a:prstGeom prst="rect">
@@ -13494,7 +13473,7 @@
         </p:nvSpPr>
         <p:spPr>
           <a:xfrm>
-            <a:off x="510241" y="2155824"/>
+            <a:off x="2034241" y="2155824"/>
             <a:ext cx="8229600" cy="658368"/>
           </a:xfrm>
           <a:prstGeom prst="rect">
@@ -13507,9 +13486,6 @@
           <a:bodyPr wrap="square" rtlCol="0" anchor="ctr"/>
           <a:lstStyle/>
           <a:p>
-            <a:pPr marL="0" indent="0">
-              <a:buNone/>
-            </a:pPr>
             <a:r>
               <a:rPr lang="en-US" sz="2400" dirty="0">
                 <a:latin typeface="+mn-lt"/>
@@ -13538,7 +13514,7 @@
         </p:nvSpPr>
         <p:spPr>
           <a:xfrm>
-            <a:off x="359426" y="4344258"/>
+            <a:off x="1883426" y="4344258"/>
             <a:ext cx="8229600" cy="384048"/>
           </a:xfrm>
           <a:prstGeom prst="rect">
@@ -13551,9 +13527,6 @@
           <a:bodyPr wrap="square" rtlCol="0" anchor="ctr"/>
           <a:lstStyle/>
           <a:p>
-            <a:pPr marL="0" indent="0">
-              <a:buNone/>
-            </a:pPr>
             <a:r>
               <a:rPr lang="en-US" sz="2000" b="1" dirty="0">
                 <a:solidFill>
@@ -13583,7 +13556,7 @@
         </p:nvSpPr>
         <p:spPr>
           <a:xfrm>
-            <a:off x="365759" y="4731382"/>
+            <a:off x="1889759" y="4731382"/>
             <a:ext cx="8412480" cy="658368"/>
           </a:xfrm>
           <a:prstGeom prst="rect">
@@ -13603,9 +13576,6 @@
           <a:bodyPr/>
           <a:lstStyle/>
           <a:p>
-            <a:pPr marL="0" indent="0">
-              <a:buNone/>
-            </a:pPr>
             <a:r>
               <a:rPr lang="en-US" sz="1800" dirty="0">
                 <a:solidFill>
@@ -13701,7 +13671,7 @@
         </p:nvSpPr>
         <p:spPr>
           <a:xfrm>
-            <a:off x="107966" y="3337670"/>
+            <a:off x="1631966" y="3337670"/>
             <a:ext cx="3749040" cy="1051560"/>
           </a:xfrm>
           <a:prstGeom prst="rect">
@@ -13739,7 +13709,7 @@
         </p:nvSpPr>
         <p:spPr>
           <a:xfrm>
-            <a:off x="359426" y="3461114"/>
+            <a:off x="1883426" y="3461114"/>
             <a:ext cx="3383280" cy="365760"/>
           </a:xfrm>
           <a:prstGeom prst="rect">
@@ -13752,9 +13722,6 @@
           <a:bodyPr wrap="square" rtlCol="0" anchor="ctr"/>
           <a:lstStyle/>
           <a:p>
-            <a:pPr marL="0" indent="0">
-              <a:buNone/>
-            </a:pPr>
             <a:r>
               <a:rPr lang="en-US" sz="1600" b="1" dirty="0">
                 <a:solidFill>
@@ -13784,7 +13751,7 @@
         </p:nvSpPr>
         <p:spPr>
           <a:xfrm>
-            <a:off x="359426" y="3845162"/>
+            <a:off x="1883426" y="3845162"/>
             <a:ext cx="3383280" cy="457200"/>
           </a:xfrm>
           <a:prstGeom prst="rect">
@@ -13797,9 +13764,6 @@
           <a:bodyPr wrap="square" rtlCol="0" anchor="ctr"/>
           <a:lstStyle/>
           <a:p>
-            <a:pPr marL="0" indent="0">
-              <a:buNone/>
-            </a:pPr>
             <a:r>
               <a:rPr lang="en-US" sz="1300" dirty="0">
                 <a:latin typeface="Calibri" pitchFamily="34" charset="0"/>
@@ -13826,7 +13790,7 @@
         </p:nvSpPr>
         <p:spPr>
           <a:xfrm>
-            <a:off x="4990801" y="3346814"/>
+            <a:off x="6514801" y="3346814"/>
             <a:ext cx="3749040" cy="1051560"/>
           </a:xfrm>
           <a:prstGeom prst="rect">
@@ -13864,7 +13828,7 @@
         </p:nvSpPr>
         <p:spPr>
           <a:xfrm>
-            <a:off x="5003472" y="3370280"/>
+            <a:off x="6527472" y="3370280"/>
             <a:ext cx="3383280" cy="365760"/>
           </a:xfrm>
           <a:prstGeom prst="rect">
@@ -13877,9 +13841,6 @@
           <a:bodyPr wrap="square" rtlCol="0" anchor="ctr"/>
           <a:lstStyle/>
           <a:p>
-            <a:pPr marL="0" indent="0">
-              <a:buNone/>
-            </a:pPr>
             <a:r>
               <a:rPr lang="en-US" sz="1550" b="1" dirty="0">
                 <a:solidFill>
@@ -13909,7 +13870,7 @@
         </p:nvSpPr>
         <p:spPr>
           <a:xfrm>
-            <a:off x="5003472" y="3754328"/>
+            <a:off x="6527472" y="3754328"/>
             <a:ext cx="3383280" cy="457200"/>
           </a:xfrm>
           <a:prstGeom prst="rect">
@@ -13922,9 +13883,6 @@
           <a:bodyPr wrap="square" rtlCol="0" anchor="ctr"/>
           <a:lstStyle/>
           <a:p>
-            <a:pPr marL="0" indent="0">
-              <a:buNone/>
-            </a:pPr>
             <a:r>
               <a:rPr lang="en-US" sz="1300" dirty="0">
                 <a:latin typeface="Calibri" pitchFamily="34" charset="0"/>
@@ -13951,7 +13909,7 @@
         </p:nvSpPr>
         <p:spPr>
           <a:xfrm rot="19522172">
-            <a:off x="3068555" y="2661153"/>
+            <a:off x="4592555" y="2661153"/>
             <a:ext cx="1189822" cy="506776"/>
           </a:xfrm>
           <a:prstGeom prst="leftArrow">
@@ -14000,7 +13958,7 @@
         </p:nvSpPr>
         <p:spPr>
           <a:xfrm rot="13377505">
-            <a:off x="4585149" y="2654227"/>
+            <a:off x="6109149" y="2654227"/>
             <a:ext cx="1189822" cy="506776"/>
           </a:xfrm>
           <a:prstGeom prst="leftArrow">
@@ -14049,7 +14007,7 @@
         </p:nvSpPr>
         <p:spPr>
           <a:xfrm>
-            <a:off x="4132030" y="2823594"/>
+            <a:off x="5656031" y="2823594"/>
             <a:ext cx="858771" cy="523220"/>
           </a:xfrm>
           <a:prstGeom prst="rect">
@@ -14084,7 +14042,7 @@
         </p:nvSpPr>
         <p:spPr>
           <a:xfrm>
-            <a:off x="2289855" y="5748932"/>
+            <a:off x="3813855" y="5748932"/>
             <a:ext cx="798846" cy="749808"/>
           </a:xfrm>
           <a:prstGeom prst="rect">
@@ -14097,9 +14055,7 @@
           <a:bodyPr wrap="square" rtlCol="0" anchor="ctr"/>
           <a:lstStyle/>
           <a:p>
-            <a:pPr marL="0" indent="0" algn="ctr">
-              <a:buNone/>
-            </a:pPr>
+            <a:pPr algn="ctr"/>
             <a:r>
               <a:rPr lang="en-US" sz="2400" dirty="0">
                 <a:solidFill>
@@ -14126,7 +14082,7 @@
         </p:nvSpPr>
         <p:spPr>
           <a:xfrm>
-            <a:off x="2907223" y="5748932"/>
+            <a:off x="4431223" y="5748932"/>
             <a:ext cx="1993392" cy="749808"/>
           </a:xfrm>
           <a:prstGeom prst="rect">
@@ -14164,7 +14120,7 @@
         </p:nvSpPr>
         <p:spPr>
           <a:xfrm>
-            <a:off x="2872444" y="5804547"/>
+            <a:off x="4396444" y="5804547"/>
             <a:ext cx="1828800" cy="683046"/>
           </a:xfrm>
           <a:prstGeom prst="rect">
@@ -14177,9 +14133,7 @@
           <a:bodyPr wrap="square" rtlCol="0" anchor="ctr"/>
           <a:lstStyle/>
           <a:p>
-            <a:pPr marL="0" indent="0" algn="ctr">
-              <a:buNone/>
-            </a:pPr>
+            <a:pPr algn="ctr"/>
             <a:r>
               <a:rPr lang="en-US" sz="1300" b="1" dirty="0">
                 <a:solidFill>
@@ -14209,7 +14163,7 @@
         </p:nvSpPr>
         <p:spPr>
           <a:xfrm>
-            <a:off x="5003472" y="5748932"/>
+            <a:off x="6527473" y="5748932"/>
             <a:ext cx="623943" cy="749808"/>
           </a:xfrm>
           <a:prstGeom prst="rect">
@@ -14222,9 +14176,7 @@
           <a:bodyPr wrap="square" rtlCol="0" anchor="ctr"/>
           <a:lstStyle/>
           <a:p>
-            <a:pPr marL="0" indent="0" algn="ctr">
-              <a:buNone/>
-            </a:pPr>
+            <a:pPr algn="ctr"/>
             <a:r>
               <a:rPr lang="en-US" sz="2400" dirty="0">
                 <a:solidFill>
@@ -14251,7 +14203,7 @@
         </p:nvSpPr>
         <p:spPr>
           <a:xfrm>
-            <a:off x="5627415" y="5748932"/>
+            <a:off x="7151415" y="5748932"/>
             <a:ext cx="2331720" cy="749808"/>
           </a:xfrm>
           <a:prstGeom prst="rect">
@@ -14264,9 +14216,7 @@
           <a:bodyPr wrap="square" rtlCol="0" anchor="ctr"/>
           <a:lstStyle/>
           <a:p>
-            <a:pPr marL="0" indent="0" algn="ctr">
-              <a:buNone/>
-            </a:pPr>
+            <a:pPr algn="ctr"/>
             <a:r>
               <a:rPr lang="en-US" sz="1300" b="1" dirty="0">
                 <a:solidFill>
@@ -14281,9 +14231,7 @@
             <a:endParaRPr lang="en-US" sz="1300" dirty="0"/>
           </a:p>
           <a:p>
-            <a:pPr marL="0" indent="0" algn="ctr">
-              <a:buNone/>
-            </a:pPr>
+            <a:pPr algn="ctr"/>
             <a:r>
               <a:rPr lang="en-US" sz="1300" b="1" dirty="0">
                 <a:solidFill>
@@ -16025,7 +15973,7 @@
         </p:nvSpPr>
         <p:spPr>
           <a:xfrm>
-            <a:off x="365760" y="3204587"/>
+            <a:off x="1889760" y="3204587"/>
             <a:ext cx="3840480" cy="3584448"/>
           </a:xfrm>
           <a:prstGeom prst="rect">
@@ -16063,7 +16011,7 @@
         </p:nvSpPr>
         <p:spPr>
           <a:xfrm>
-            <a:off x="4937760" y="3204587"/>
+            <a:off x="6461760" y="3204587"/>
             <a:ext cx="3840480" cy="3584448"/>
           </a:xfrm>
           <a:prstGeom prst="rect">
@@ -16101,7 +16049,7 @@
         </p:nvSpPr>
         <p:spPr>
           <a:xfrm>
-            <a:off x="4206240" y="4247003"/>
+            <a:off x="5730240" y="4247003"/>
             <a:ext cx="731520" cy="777240"/>
           </a:xfrm>
           <a:prstGeom prst="rect">
@@ -16114,9 +16062,7 @@
           <a:bodyPr wrap="square" rtlCol="0" anchor="ctr"/>
           <a:lstStyle/>
           <a:p>
-            <a:pPr marL="0" indent="0" algn="ctr">
-              <a:buNone/>
-            </a:pPr>
+            <a:pPr algn="ctr"/>
             <a:r>
               <a:rPr lang="en-US" sz="2600" b="1" dirty="0">
                 <a:solidFill>
@@ -16143,7 +16089,7 @@
         </p:nvSpPr>
         <p:spPr>
           <a:xfrm>
-            <a:off x="365760" y="3204587"/>
+            <a:off x="1889760" y="3204587"/>
             <a:ext cx="3840480" cy="3584448"/>
           </a:xfrm>
           <a:prstGeom prst="rect">
@@ -16184,7 +16130,7 @@
         </p:nvSpPr>
         <p:spPr>
           <a:xfrm>
-            <a:off x="566928" y="3296027"/>
+            <a:off x="2090928" y="3296027"/>
             <a:ext cx="3456432" cy="475488"/>
           </a:xfrm>
           <a:prstGeom prst="rect">
@@ -16197,9 +16143,6 @@
           <a:bodyPr wrap="square" rtlCol="0" anchor="ctr"/>
           <a:lstStyle/>
           <a:p>
-            <a:pPr marL="0" indent="0">
-              <a:buNone/>
-            </a:pPr>
             <a:r>
               <a:rPr lang="en-US" sz="1250" dirty="0">
                 <a:solidFill>
@@ -16229,7 +16172,7 @@
         </p:nvSpPr>
         <p:spPr>
           <a:xfrm>
-            <a:off x="566928" y="3817235"/>
+            <a:off x="2090928" y="3817235"/>
             <a:ext cx="3456432" cy="475488"/>
           </a:xfrm>
           <a:prstGeom prst="rect">
@@ -16242,9 +16185,6 @@
           <a:bodyPr wrap="square" rtlCol="0" anchor="ctr"/>
           <a:lstStyle/>
           <a:p>
-            <a:pPr marL="0" indent="0">
-              <a:buNone/>
-            </a:pPr>
             <a:r>
               <a:rPr lang="en-US" sz="1250" dirty="0">
                 <a:solidFill>
@@ -16274,7 +16214,7 @@
         </p:nvSpPr>
         <p:spPr>
           <a:xfrm>
-            <a:off x="566928" y="4338443"/>
+            <a:off x="2090928" y="4338443"/>
             <a:ext cx="3456432" cy="475488"/>
           </a:xfrm>
           <a:prstGeom prst="rect">
@@ -16287,9 +16227,6 @@
           <a:bodyPr wrap="square" rtlCol="0" anchor="ctr"/>
           <a:lstStyle/>
           <a:p>
-            <a:pPr marL="0" indent="0">
-              <a:buNone/>
-            </a:pPr>
             <a:r>
               <a:rPr lang="en-US" sz="1250" dirty="0">
                 <a:solidFill>
@@ -16319,7 +16256,7 @@
         </p:nvSpPr>
         <p:spPr>
           <a:xfrm>
-            <a:off x="566928" y="4859651"/>
+            <a:off x="2090928" y="4859651"/>
             <a:ext cx="3456432" cy="475488"/>
           </a:xfrm>
           <a:prstGeom prst="rect">
@@ -16332,9 +16269,6 @@
           <a:bodyPr wrap="square" rtlCol="0" anchor="ctr"/>
           <a:lstStyle/>
           <a:p>
-            <a:pPr marL="0" indent="0">
-              <a:buNone/>
-            </a:pPr>
             <a:r>
               <a:rPr lang="en-US" sz="1250" dirty="0">
                 <a:solidFill>
@@ -16364,7 +16298,7 @@
         </p:nvSpPr>
         <p:spPr>
           <a:xfrm>
-            <a:off x="566928" y="5380859"/>
+            <a:off x="2090928" y="5380859"/>
             <a:ext cx="3456432" cy="475488"/>
           </a:xfrm>
           <a:prstGeom prst="rect">
@@ -16377,9 +16311,6 @@
           <a:bodyPr wrap="square" rtlCol="0" anchor="ctr"/>
           <a:lstStyle/>
           <a:p>
-            <a:pPr marL="0" indent="0">
-              <a:buNone/>
-            </a:pPr>
             <a:r>
               <a:rPr lang="en-US" sz="1250" dirty="0">
                 <a:solidFill>
@@ -16409,7 +16340,7 @@
         </p:nvSpPr>
         <p:spPr>
           <a:xfrm>
-            <a:off x="566928" y="5902067"/>
+            <a:off x="2090928" y="5902067"/>
             <a:ext cx="3456432" cy="475488"/>
           </a:xfrm>
           <a:prstGeom prst="rect">
@@ -16422,9 +16353,6 @@
           <a:bodyPr wrap="square" rtlCol="0" anchor="ctr"/>
           <a:lstStyle/>
           <a:p>
-            <a:pPr marL="0" indent="0">
-              <a:buNone/>
-            </a:pPr>
             <a:r>
               <a:rPr lang="en-US" sz="1250" dirty="0">
                 <a:solidFill>
@@ -16454,7 +16382,7 @@
         </p:nvSpPr>
         <p:spPr>
           <a:xfrm>
-            <a:off x="374904" y="2747132"/>
+            <a:off x="1898904" y="2747132"/>
             <a:ext cx="3840480" cy="475488"/>
           </a:xfrm>
           <a:prstGeom prst="rect">
@@ -16498,7 +16426,7 @@
         </p:nvSpPr>
         <p:spPr>
           <a:xfrm>
-            <a:off x="5312664" y="3341747"/>
+            <a:off x="6836664" y="3341747"/>
             <a:ext cx="3456432" cy="475488"/>
           </a:xfrm>
           <a:prstGeom prst="rect">
@@ -16511,9 +16439,6 @@
           <a:bodyPr wrap="square" rtlCol="0" anchor="ctr"/>
           <a:lstStyle/>
           <a:p>
-            <a:pPr marL="0" indent="0">
-              <a:buNone/>
-            </a:pPr>
             <a:r>
               <a:rPr lang="en-US" sz="1250" dirty="0">
                 <a:solidFill>
@@ -16543,7 +16468,7 @@
         </p:nvSpPr>
         <p:spPr>
           <a:xfrm>
-            <a:off x="5312664" y="3862955"/>
+            <a:off x="6836664" y="3862955"/>
             <a:ext cx="3456432" cy="475488"/>
           </a:xfrm>
           <a:prstGeom prst="rect">
@@ -16556,9 +16481,6 @@
           <a:bodyPr wrap="square" rtlCol="0" anchor="ctr"/>
           <a:lstStyle/>
           <a:p>
-            <a:pPr marL="0" indent="0">
-              <a:buNone/>
-            </a:pPr>
             <a:r>
               <a:rPr lang="en-US" sz="1250" dirty="0">
                 <a:solidFill>
@@ -16588,7 +16510,7 @@
         </p:nvSpPr>
         <p:spPr>
           <a:xfrm>
-            <a:off x="5312664" y="4384163"/>
+            <a:off x="6836664" y="4384163"/>
             <a:ext cx="3456432" cy="475488"/>
           </a:xfrm>
           <a:prstGeom prst="rect">
@@ -16601,9 +16523,6 @@
           <a:bodyPr wrap="square" rtlCol="0" anchor="ctr"/>
           <a:lstStyle/>
           <a:p>
-            <a:pPr marL="0" indent="0">
-              <a:buNone/>
-            </a:pPr>
             <a:r>
               <a:rPr lang="en-US" sz="1250" dirty="0">
                 <a:solidFill>
@@ -16633,7 +16552,7 @@
         </p:nvSpPr>
         <p:spPr>
           <a:xfrm>
-            <a:off x="5312664" y="4905371"/>
+            <a:off x="6836664" y="4905371"/>
             <a:ext cx="3456432" cy="475488"/>
           </a:xfrm>
           <a:prstGeom prst="rect">
@@ -16646,9 +16565,6 @@
           <a:bodyPr wrap="square" rtlCol="0" anchor="ctr"/>
           <a:lstStyle/>
           <a:p>
-            <a:pPr marL="0" indent="0">
-              <a:buNone/>
-            </a:pPr>
             <a:r>
               <a:rPr lang="en-US" sz="1250" dirty="0">
                 <a:solidFill>
@@ -16678,7 +16594,7 @@
         </p:nvSpPr>
         <p:spPr>
           <a:xfrm>
-            <a:off x="5312664" y="5426579"/>
+            <a:off x="6836664" y="5426579"/>
             <a:ext cx="3456432" cy="475488"/>
           </a:xfrm>
           <a:prstGeom prst="rect">
@@ -16691,9 +16607,6 @@
           <a:bodyPr wrap="square" rtlCol="0" anchor="ctr"/>
           <a:lstStyle/>
           <a:p>
-            <a:pPr marL="0" indent="0">
-              <a:buNone/>
-            </a:pPr>
             <a:r>
               <a:rPr lang="en-US" sz="1250" dirty="0">
                 <a:solidFill>
@@ -16723,7 +16636,7 @@
         </p:nvSpPr>
         <p:spPr>
           <a:xfrm>
-            <a:off x="5312664" y="5947787"/>
+            <a:off x="6836664" y="5947787"/>
             <a:ext cx="3456432" cy="475488"/>
           </a:xfrm>
           <a:prstGeom prst="rect">
@@ -16736,9 +16649,6 @@
           <a:bodyPr wrap="square" rtlCol="0" anchor="ctr"/>
           <a:lstStyle/>
           <a:p>
-            <a:pPr marL="0" indent="0">
-              <a:buNone/>
-            </a:pPr>
             <a:r>
               <a:rPr lang="en-US" sz="1250" dirty="0">
                 <a:solidFill>
@@ -16768,7 +16678,7 @@
         </p:nvSpPr>
         <p:spPr>
           <a:xfrm>
-            <a:off x="4928616" y="2719955"/>
+            <a:off x="6452616" y="2719955"/>
             <a:ext cx="3840480" cy="475488"/>
           </a:xfrm>
           <a:prstGeom prst="rect">
@@ -16783,9 +16693,7 @@
           <a:bodyPr wrap="square" rtlCol="0" anchor="ctr"/>
           <a:lstStyle/>
           <a:p>
-            <a:pPr marL="0" indent="0" algn="ctr">
-              <a:buNone/>
-            </a:pPr>
+            <a:pPr algn="ctr"/>
             <a:r>
               <a:rPr lang="en-US" dirty="0"/>
               <a:t>newtype  (wrapper)</a:t>
@@ -17988,7 +17896,7 @@
         </p:nvSpPr>
         <p:spPr>
           <a:xfrm>
-            <a:off x="433122" y="800211"/>
+            <a:off x="1957122" y="800211"/>
             <a:ext cx="7210396" cy="1080938"/>
           </a:xfrm>
         </p:spPr>
@@ -18060,7 +17968,7 @@
         </p:nvSpPr>
         <p:spPr>
           <a:xfrm>
-            <a:off x="638978" y="2434728"/>
+            <a:off x="2162979" y="2434728"/>
             <a:ext cx="8064347" cy="523220"/>
           </a:xfrm>
           <a:prstGeom prst="rect">
@@ -18097,7 +18005,7 @@
         </p:nvSpPr>
         <p:spPr bwMode="auto">
           <a:xfrm>
-            <a:off x="1269392" y="3049862"/>
+            <a:off x="2793392" y="3049863"/>
             <a:ext cx="3717684" cy="461665"/>
           </a:xfrm>
           <a:prstGeom prst="rect">
@@ -18144,7 +18052,7 @@
         </p:nvSpPr>
         <p:spPr>
           <a:xfrm>
-            <a:off x="638978" y="3638443"/>
+            <a:off x="2162979" y="3638443"/>
             <a:ext cx="8064347" cy="523220"/>
           </a:xfrm>
           <a:prstGeom prst="rect">
@@ -18181,7 +18089,7 @@
         </p:nvSpPr>
         <p:spPr bwMode="auto">
           <a:xfrm>
-            <a:off x="1269392" y="4288579"/>
+            <a:off x="2793392" y="4288580"/>
             <a:ext cx="7808548" cy="461665"/>
           </a:xfrm>
           <a:prstGeom prst="rect">
@@ -18230,7 +18138,7 @@
         </p:nvSpPr>
         <p:spPr bwMode="auto">
           <a:xfrm>
-            <a:off x="1269392" y="5504607"/>
+            <a:off x="2793392" y="5504608"/>
             <a:ext cx="7622600" cy="1200329"/>
           </a:xfrm>
           <a:prstGeom prst="rect">
@@ -18319,7 +18227,7 @@
         </p:nvSpPr>
         <p:spPr>
           <a:xfrm>
-            <a:off x="638978" y="4981387"/>
+            <a:off x="2162979" y="4981387"/>
             <a:ext cx="8516039" cy="523220"/>
           </a:xfrm>
           <a:prstGeom prst="rect">
@@ -18724,7 +18632,7 @@
         </p:nvSpPr>
         <p:spPr>
           <a:xfrm>
-            <a:off x="510241" y="2336873"/>
+            <a:off x="2034241" y="2336874"/>
             <a:ext cx="7210396" cy="2006527"/>
           </a:xfrm>
         </p:spPr>
@@ -19111,7 +19019,7 @@
         </p:nvSpPr>
         <p:spPr>
           <a:xfrm>
-            <a:off x="475458" y="2085519"/>
+            <a:off x="1999458" y="2085519"/>
             <a:ext cx="8193084" cy="2686962"/>
           </a:xfrm>
           <a:solidFill>
@@ -19387,7 +19295,7 @@
         </p:nvSpPr>
         <p:spPr>
           <a:xfrm>
-            <a:off x="80041" y="1994903"/>
+            <a:off x="1604041" y="1994903"/>
             <a:ext cx="3391128" cy="1530892"/>
           </a:xfrm>
           <a:solidFill>
@@ -19573,7 +19481,7 @@
         </p:nvSpPr>
         <p:spPr>
           <a:xfrm>
-            <a:off x="242686" y="3776719"/>
+            <a:off x="1766686" y="3776719"/>
             <a:ext cx="8046720" cy="347472"/>
           </a:xfrm>
           <a:prstGeom prst="rect">
@@ -19586,9 +19494,6 @@
           <a:bodyPr wrap="square" rtlCol="0" anchor="ctr"/>
           <a:lstStyle/>
           <a:p>
-            <a:pPr marL="0" indent="0">
-              <a:buNone/>
-            </a:pPr>
             <a:r>
               <a:rPr lang="en-US" sz="1250" b="1" dirty="0">
                 <a:latin typeface="Consolas" pitchFamily="34" charset="0"/>
@@ -19634,7 +19539,7 @@
         </p:nvSpPr>
         <p:spPr>
           <a:xfrm>
-            <a:off x="242686" y="4201379"/>
+            <a:off x="1766686" y="4201379"/>
             <a:ext cx="8046720" cy="347472"/>
           </a:xfrm>
           <a:prstGeom prst="rect">
@@ -19647,9 +19552,6 @@
           <a:bodyPr wrap="square" rtlCol="0" anchor="ctr"/>
           <a:lstStyle/>
           <a:p>
-            <a:pPr marL="0" indent="0">
-              <a:buNone/>
-            </a:pPr>
             <a:r>
               <a:rPr lang="en-US" sz="1250" b="1" dirty="0">
                 <a:solidFill>
@@ -19687,7 +19589,7 @@
         </p:nvSpPr>
         <p:spPr>
           <a:xfrm>
-            <a:off x="242686" y="4666512"/>
+            <a:off x="1766686" y="4666512"/>
             <a:ext cx="8720996" cy="347472"/>
           </a:xfrm>
           <a:prstGeom prst="rect">
@@ -19700,9 +19602,6 @@
           <a:bodyPr wrap="square" rtlCol="0" anchor="ctr"/>
           <a:lstStyle/>
           <a:p>
-            <a:pPr marL="0" indent="0">
-              <a:buNone/>
-            </a:pPr>
             <a:r>
               <a:rPr lang="en-US" sz="1250" b="1" dirty="0">
                 <a:solidFill>
@@ -19751,7 +19650,7 @@
         </p:nvSpPr>
         <p:spPr>
           <a:xfrm>
-            <a:off x="242686" y="5131645"/>
+            <a:off x="1766686" y="5131645"/>
             <a:ext cx="8046720" cy="347472"/>
           </a:xfrm>
           <a:prstGeom prst="rect">
@@ -19764,9 +19663,6 @@
           <a:bodyPr wrap="square" rtlCol="0" anchor="ctr"/>
           <a:lstStyle/>
           <a:p>
-            <a:pPr marL="0" indent="0">
-              <a:buNone/>
-            </a:pPr>
             <a:r>
               <a:rPr lang="en-US" sz="1250" b="1" dirty="0">
                 <a:solidFill>
@@ -19812,7 +19708,7 @@
         </p:nvSpPr>
         <p:spPr>
           <a:xfrm>
-            <a:off x="242686" y="5596778"/>
+            <a:off x="1766686" y="5596778"/>
             <a:ext cx="8046720" cy="347472"/>
           </a:xfrm>
           <a:prstGeom prst="rect">
@@ -19825,9 +19721,6 @@
           <a:bodyPr wrap="square" rtlCol="0" anchor="ctr"/>
           <a:lstStyle/>
           <a:p>
-            <a:pPr marL="0" indent="0">
-              <a:buNone/>
-            </a:pPr>
             <a:r>
               <a:rPr lang="en-US" sz="1250" b="1" dirty="0">
                 <a:solidFill>
@@ -19873,7 +19766,7 @@
         </p:nvSpPr>
         <p:spPr>
           <a:xfrm>
-            <a:off x="242686" y="6042064"/>
+            <a:off x="1766686" y="6042064"/>
             <a:ext cx="8046720" cy="347472"/>
           </a:xfrm>
           <a:prstGeom prst="rect">
@@ -19886,9 +19779,6 @@
           <a:bodyPr wrap="square" rtlCol="0" anchor="ctr"/>
           <a:lstStyle/>
           <a:p>
-            <a:pPr marL="0" indent="0">
-              <a:buNone/>
-            </a:pPr>
             <a:r>
               <a:rPr lang="en-US" sz="1250" b="1" dirty="0">
                 <a:solidFill>
@@ -20609,7 +20499,7 @@
         </p:nvSpPr>
         <p:spPr>
           <a:xfrm>
-            <a:off x="5394312" y="2152881"/>
+            <a:off x="6918312" y="2152881"/>
             <a:ext cx="3349638" cy="438912"/>
           </a:xfrm>
           <a:prstGeom prst="rect">
@@ -20624,9 +20514,6 @@
           <a:bodyPr wrap="square" rtlCol="0" anchor="ctr"/>
           <a:lstStyle/>
           <a:p>
-            <a:pPr marL="0" indent="0">
-              <a:buNone/>
-            </a:pPr>
             <a:r>
               <a:rPr lang="en-US" sz="1600" b="1" dirty="0">
                 <a:solidFill>
@@ -20678,7 +20565,7 @@
         </p:nvSpPr>
         <p:spPr>
           <a:xfrm>
-            <a:off x="294121" y="2767478"/>
+            <a:off x="1818121" y="2767478"/>
             <a:ext cx="2725862" cy="502920"/>
           </a:xfrm>
           <a:prstGeom prst="rect">
@@ -20698,9 +20585,6 @@
           <a:bodyPr/>
           <a:lstStyle/>
           <a:p>
-            <a:pPr marL="0" indent="0">
-              <a:buNone/>
-            </a:pPr>
             <a:r>
               <a:rPr lang="en-US" sz="1600" b="1" dirty="0" err="1">
                 <a:solidFill>
@@ -20778,7 +20662,7 @@
         </p:nvSpPr>
         <p:spPr>
           <a:xfrm>
-            <a:off x="294121" y="3639896"/>
+            <a:off x="1818122" y="3639896"/>
             <a:ext cx="2358843" cy="502920"/>
           </a:xfrm>
           <a:prstGeom prst="rect">
@@ -20793,9 +20677,6 @@
           <a:bodyPr wrap="square" rtlCol="0" anchor="ctr"/>
           <a:lstStyle/>
           <a:p>
-            <a:pPr marL="0" indent="0">
-              <a:buNone/>
-            </a:pPr>
             <a:r>
               <a:rPr lang="en-US" sz="1600" b="1" dirty="0">
                 <a:solidFill>
@@ -20823,7 +20704,7 @@
         </p:nvSpPr>
         <p:spPr>
           <a:xfrm>
-            <a:off x="294121" y="4512314"/>
+            <a:off x="1818122" y="4512315"/>
             <a:ext cx="3513381" cy="1235477"/>
           </a:xfrm>
           <a:prstGeom prst="rect">
@@ -20843,9 +20724,6 @@
           <a:bodyPr/>
           <a:lstStyle/>
           <a:p>
-            <a:pPr marL="0" indent="0">
-              <a:buNone/>
-            </a:pPr>
             <a:r>
               <a:rPr lang="en-US" sz="1400" dirty="0">
                 <a:solidFill>
@@ -20882,9 +20760,6 @@
             <a:endParaRPr lang="en-US" sz="1400" dirty="0"/>
           </a:p>
           <a:p>
-            <a:pPr marL="0" indent="0">
-              <a:buNone/>
-            </a:pPr>
             <a:r>
               <a:rPr lang="en-US" sz="1400" dirty="0">
                 <a:solidFill>
@@ -20899,15 +20774,9 @@
             <a:endParaRPr lang="en-US" sz="1400" dirty="0"/>
           </a:p>
           <a:p>
-            <a:pPr marL="0" indent="0">
-              <a:buNone/>
-            </a:pPr>
             <a:endParaRPr lang="en-US" sz="1400" dirty="0"/>
           </a:p>
           <a:p>
-            <a:pPr marL="0" indent="0">
-              <a:buNone/>
-            </a:pPr>
             <a:r>
               <a:rPr lang="en-US" sz="1400" dirty="0">
                 <a:solidFill>
@@ -20944,9 +20813,6 @@
             <a:endParaRPr lang="en-US" sz="1400" dirty="0"/>
           </a:p>
           <a:p>
-            <a:pPr marL="0" indent="0">
-              <a:buNone/>
-            </a:pPr>
             <a:r>
               <a:rPr lang="en-US" sz="1400" dirty="0">
                 <a:solidFill>
@@ -20998,7 +20864,7 @@
         </p:nvSpPr>
         <p:spPr>
           <a:xfrm>
-            <a:off x="294121" y="2187952"/>
+            <a:off x="1818122" y="2187952"/>
             <a:ext cx="3138627" cy="438912"/>
           </a:xfrm>
           <a:prstGeom prst="rect">
@@ -21018,9 +20884,6 @@
           <a:bodyPr/>
           <a:lstStyle/>
           <a:p>
-            <a:pPr marL="0" indent="0">
-              <a:buNone/>
-            </a:pPr>
             <a:r>
               <a:rPr lang="en-US" sz="1600" b="1" dirty="0">
                 <a:solidFill>
@@ -21068,7 +20931,7 @@
         </p:nvSpPr>
         <p:spPr>
           <a:xfrm>
-            <a:off x="5394312" y="2790335"/>
+            <a:off x="6918312" y="2790335"/>
             <a:ext cx="3463136" cy="502920"/>
           </a:xfrm>
           <a:prstGeom prst="rect">
@@ -21088,9 +20951,6 @@
           <a:bodyPr/>
           <a:lstStyle/>
           <a:p>
-            <a:pPr marL="0" indent="0">
-              <a:buNone/>
-            </a:pPr>
             <a:r>
               <a:rPr lang="en-US" sz="1600" b="1" dirty="0">
                 <a:solidFill>
@@ -21175,7 +21035,7 @@
         </p:nvSpPr>
         <p:spPr>
           <a:xfrm>
-            <a:off x="5511372" y="3639896"/>
+            <a:off x="7035372" y="3639896"/>
             <a:ext cx="2968526" cy="502920"/>
           </a:xfrm>
           <a:prstGeom prst="rect">
@@ -21217,7 +21077,7 @@
         </p:nvSpPr>
         <p:spPr>
           <a:xfrm>
-            <a:off x="5482466" y="4515496"/>
+            <a:off x="7006466" y="4515497"/>
             <a:ext cx="3026338" cy="1235477"/>
           </a:xfrm>
           <a:prstGeom prst="rect">
@@ -21329,7 +21189,7 @@
         </p:nvSpPr>
         <p:spPr>
           <a:xfrm>
-            <a:off x="343050" y="6028266"/>
+            <a:off x="1867050" y="6028266"/>
             <a:ext cx="8229600" cy="594360"/>
           </a:xfrm>
           <a:prstGeom prst="rect">
@@ -21344,9 +21204,6 @@
           <a:bodyPr wrap="square" rtlCol="0" anchor="ctr"/>
           <a:lstStyle/>
           <a:p>
-            <a:pPr marL="0" indent="0">
-              <a:buNone/>
-            </a:pPr>
             <a:r>
               <a:rPr lang="en-US" sz="1800" dirty="0">
                 <a:solidFill>
@@ -22270,7 +22127,7 @@
         </p:nvSpPr>
         <p:spPr>
           <a:xfrm>
-            <a:off x="0" y="753228"/>
+            <a:off x="1524000" y="753228"/>
             <a:ext cx="8047092" cy="1080938"/>
           </a:xfrm>
         </p:spPr>
@@ -22343,7 +22200,7 @@
         </p:nvSpPr>
         <p:spPr>
           <a:xfrm>
-            <a:off x="2236483" y="1992254"/>
+            <a:off x="3760483" y="1992254"/>
             <a:ext cx="4663440" cy="384048"/>
           </a:xfrm>
           <a:prstGeom prst="rect">
@@ -22356,9 +22213,6 @@
           <a:bodyPr wrap="square" rtlCol="0" anchor="ctr"/>
           <a:lstStyle/>
           <a:p>
-            <a:pPr marL="0" indent="0">
-              <a:buNone/>
-            </a:pPr>
             <a:r>
               <a:rPr lang="en-US" sz="1500" dirty="0">
                 <a:solidFill>
@@ -22388,7 +22242,7 @@
         </p:nvSpPr>
         <p:spPr>
           <a:xfrm>
-            <a:off x="356334" y="3132528"/>
+            <a:off x="1880334" y="3132528"/>
             <a:ext cx="3794760" cy="1188720"/>
           </a:xfrm>
           <a:prstGeom prst="rect">
@@ -22426,7 +22280,7 @@
         </p:nvSpPr>
         <p:spPr>
           <a:xfrm>
-            <a:off x="424914" y="3153180"/>
+            <a:off x="1948914" y="3153180"/>
             <a:ext cx="3474720" cy="411480"/>
           </a:xfrm>
           <a:prstGeom prst="rect">
@@ -22439,9 +22293,6 @@
           <a:bodyPr wrap="square" rtlCol="0" anchor="ctr"/>
           <a:lstStyle/>
           <a:p>
-            <a:pPr marL="0" indent="0">
-              <a:buNone/>
-            </a:pPr>
             <a:r>
               <a:rPr lang="en-US" sz="2000" b="1" dirty="0">
                 <a:solidFill>
@@ -22471,7 +22322,7 @@
         </p:nvSpPr>
         <p:spPr>
           <a:xfrm>
-            <a:off x="424914" y="3524219"/>
+            <a:off x="1948914" y="3524219"/>
             <a:ext cx="3474720" cy="621792"/>
           </a:xfrm>
           <a:prstGeom prst="rect">
@@ -22484,9 +22335,6 @@
           <a:bodyPr wrap="square" rtlCol="0" anchor="ctr"/>
           <a:lstStyle/>
           <a:p>
-            <a:pPr marL="0" indent="0">
-              <a:buNone/>
-            </a:pPr>
             <a:r>
               <a:rPr lang="en-US" sz="1250" dirty="0">
                 <a:solidFill>
@@ -22516,7 +22364,7 @@
         </p:nvSpPr>
         <p:spPr>
           <a:xfrm>
-            <a:off x="4992908" y="3132528"/>
+            <a:off x="6516908" y="3132528"/>
             <a:ext cx="3794760" cy="1188720"/>
           </a:xfrm>
           <a:prstGeom prst="rect">
@@ -22554,7 +22402,7 @@
         </p:nvSpPr>
         <p:spPr>
           <a:xfrm>
-            <a:off x="5221508" y="3223968"/>
+            <a:off x="6745508" y="3223968"/>
             <a:ext cx="3474720" cy="411480"/>
           </a:xfrm>
           <a:prstGeom prst="rect">
@@ -22567,9 +22415,6 @@
           <a:bodyPr wrap="square" rtlCol="0" anchor="ctr"/>
           <a:lstStyle/>
           <a:p>
-            <a:pPr marL="0" indent="0">
-              <a:buNone/>
-            </a:pPr>
             <a:r>
               <a:rPr lang="en-US" sz="2000" b="1" dirty="0">
                 <a:solidFill>
@@ -22599,7 +22444,7 @@
         </p:nvSpPr>
         <p:spPr>
           <a:xfrm>
-            <a:off x="5221508" y="3635448"/>
+            <a:off x="6745508" y="3635448"/>
             <a:ext cx="3474720" cy="621792"/>
           </a:xfrm>
           <a:prstGeom prst="rect">
@@ -22612,9 +22457,6 @@
           <a:bodyPr wrap="square" rtlCol="0" anchor="ctr"/>
           <a:lstStyle/>
           <a:p>
-            <a:pPr marL="0" indent="0">
-              <a:buNone/>
-            </a:pPr>
             <a:r>
               <a:rPr lang="en-US" sz="1250" dirty="0">
                 <a:solidFill>
@@ -22644,7 +22486,7 @@
         </p:nvSpPr>
         <p:spPr>
           <a:xfrm rot="19522172">
-            <a:off x="3076360" y="2474227"/>
+            <a:off x="4600360" y="2474228"/>
             <a:ext cx="1189822" cy="465947"/>
           </a:xfrm>
           <a:prstGeom prst="leftArrow">
@@ -22693,7 +22535,7 @@
         </p:nvSpPr>
         <p:spPr>
           <a:xfrm rot="13377505">
-            <a:off x="4695085" y="2515669"/>
+            <a:off x="6219085" y="2515670"/>
             <a:ext cx="1042414" cy="465947"/>
           </a:xfrm>
           <a:prstGeom prst="leftArrow">
@@ -22742,7 +22584,7 @@
         </p:nvSpPr>
         <p:spPr>
           <a:xfrm>
-            <a:off x="4128234" y="2599457"/>
+            <a:off x="5652235" y="2599457"/>
             <a:ext cx="858771" cy="523220"/>
           </a:xfrm>
           <a:prstGeom prst="rect">
@@ -22777,7 +22619,7 @@
         </p:nvSpPr>
         <p:spPr>
           <a:xfrm>
-            <a:off x="216650" y="4481551"/>
+            <a:off x="1740650" y="4481552"/>
             <a:ext cx="8918866" cy="2431435"/>
           </a:xfrm>
           <a:prstGeom prst="rect">

</xml_diff>